<commit_message>
docs: align README, PPTX, and HTML deck with official 5 judging criteria (Learning Value 25%, Prompt Engineering 20%, UX 15%, Rapid Prototyping 15%, Technical Creativity 15%)
</commit_message>
<xml_diff>
--- a/AfriCloud_AZ900_Pitch_Deck.pptx
+++ b/AfriCloud_AZ900_Pitch_Deck.pptx
@@ -506,7 +506,7 @@
           <a:lstStyle/>
           <a:p>
             <a:r>
-              <a:t>Hello judges! Like many of you in the #1MillionDevs movement, I prepared for AZ-900 and experienced the anxiety of studying blind. You spend weeks memorizing answers, but you still ask yourself: 'Am I actually ready to risk $99 on the real exam?' Traditional prep tools give you a raw test percentage with zero cognitive diagnosis. We built the tool we wished we had when we started our cloud journey.</a:t>
+              <a:t>Welcome judges! Criterion 1 is Learning Value (25%), and AfriCloud was engineered from the ground up for genuine exam readiness. Unlike flat quiz apps that give a false sense of confidence, we model Microsoft's exact syllabus weighting: 27.5% Concepts, 37.5% Architecture, and 35% Governance. More importantly, we eliminate the 'Why Is This Wrong' gap—every scenario question breaks down all three wrong answers, paired with active-recall flashcard memory locks.</a:t>
             </a:r>
           </a:p>
         </p:txBody>
@@ -576,7 +576,7 @@
           <a:lstStyle/>
           <a:p>
             <a:r>
-              <a:t>Meet AfriCloud AZ-900. Instead of a static quiz app, it's an intelligent learning companion. As you see on screen, our Readiness Gauge models your probability of passing based on Microsoft's exact domain weighting. When a weakness is detected—like Azure Networking dropping below 70%—our closed-loop engine doesn't just show a red bar: it automatically schedules an offline study alert, flags a Weakness Pitstop on your roadmap, and provides targeted revision in your personal learning style.</a:t>
+              <a:t>For Prompt Engineering (20%), we built 'Rafiki'—a culturally grounded cloud mentor. Our system instructions in geminiService.js enforce strict curriculum boundaries to prevent hallucination, while dynamically injecting the learner's VARK learning style and dialect. Abstract cloud concepts like High Availability and ExpressRoute are systematically mapped to everyday African realities like M-Pesa float distribution and SGR rail networks.</a:t>
             </a:r>
           </a:p>
         </p:txBody>
@@ -646,7 +646,7 @@
           <a:lstStyle/>
           <a:p>
             <a:r>
-              <a:t>Who did we build this for? For the 1 Million Devs across the African continent. For the university student in Nairobi studying on a smartphone, the junior dev in Lagos battling unpredictable internet, and the career transitioner in Kigali. By speaking their language—literally offering explanations in English, Swahili, and Pidgin—we bridge the gap between complex cloud architecture and daily African life.</a:t>
+              <a:t>In User Experience &amp; Vibes (15%), we designed an interface that makes cloud prep addictive rather than exhausting. Learners travel a 4-level visual roadmap with confetti celebrations, sound synthesizer chimes, and instant VARK style switching. Equally important is inclusion: AfriCloud targets WCAG 2.1 AAA compliance with offline text-to-speech, dyslexia typography, and full keyboard navigation.</a:t>
             </a:r>
           </a:p>
         </p:txBody>
@@ -716,7 +716,7 @@
           <a:lstStyle/>
           <a:p>
             <a:r>
-              <a:t>Inclusion is at the core of our architecture. AfriCloud targets WCAG 2.1 AAA accessibility. Sighted or visually impaired, neurodivergent or motor-impaired—every learner has full access via offline text-to-speech read-aloud and keyboard shortcuts. Furthermore, our cognitive tracking engine is completely modular: the same code that powers AZ-900 today can power AWS Cloud Practitioner, Google Cloud Leader, or advanced Azure certifications tomorrow.</a:t>
+              <a:t>Rapid Prototyping &amp; Execution (15%) demonstrates how much can be achieved with modern vibe coding. In under 48 hours, we delivered a production React 19 app, deployed globally on Vercel, with an offline Progressive Web App Service Worker that lets students study seamlessly through power outages or low-data commutes.</a:t>
             </a:r>
           </a:p>
         </p:txBody>
@@ -786,7 +786,7 @@
           <a:lstStyle/>
           <a:p>
             <a:r>
-              <a:t>We built AfriCloud AZ-900 in under 48 hours using the full power of modern vibe coding—Vite, Tailwind CSS, Service Workers, and Gemini AI. The code is open source, production-built, and running live. We invite all the judges and fellow 1M Devs learners to scan the QR code, take a 1-minute vibe quiz, and experience the future of adaptive certification prep. Let's vibe code for learning!</a:t>
+              <a:t>Finally, Technical Creativity (15%): we used browser APIs in clever ways—zero-dependency Web Audio synthesizers for instant sound feedback, background Service Worker notification alarms that fire even with closed tabs, and a mathematical readiness radar. The project is open source and running live. Scan the QR code or visit az900-vibe-agent.vercel.app to experience AfriCloud right now!</a:t>
             </a:r>
           </a:p>
         </p:txBody>
@@ -3844,7 +3844,7 @@
         <p:spPr>
           <a:xfrm>
             <a:off x="731520" y="365760"/>
-            <a:ext cx="4206240" cy="320040"/>
+            <a:ext cx="5303520" cy="320040"/>
           </a:xfrm>
           <a:prstGeom prst="roundRect">
             <a:avLst/>
@@ -3883,7 +3883,7 @@
               </a:defRPr>
             </a:pPr>
             <a:r>
-              <a:t>VIBE CODING HACKATHON 2026  |  TRACK: 📊 READINESS TRACKER</a:t>
+              <a:t>RUBRIC CRITERION 1: 📚 LEARNING VALUE  |  WEIGHT: 25%</a:t>
             </a:r>
           </a:p>
         </p:txBody>
@@ -3911,7 +3911,7 @@
           <a:lstStyle/>
           <a:p>
             <a:pPr>
-              <a:defRPr sz="2400" b="1">
+              <a:defRPr sz="2300" b="1">
                 <a:solidFill>
                   <a:srgbClr val="F8FAFC"/>
                 </a:solidFill>
@@ -3919,7 +3919,7 @@
               </a:defRPr>
             </a:pPr>
             <a:r>
-              <a:t>AfriCloud AZ-900: Cognitive Readiness &amp; Adaptive Coach</a:t>
+              <a:t>AfriCloud AZ-900: Rigorous Pedagogical Mastery</a:t>
             </a:r>
           </a:p>
         </p:txBody>
@@ -3947,7 +3947,7 @@
           <a:lstStyle/>
           <a:p>
             <a:pPr>
-              <a:defRPr sz="1300" i="1">
+              <a:defRPr sz="1250" i="1">
                 <a:solidFill>
                   <a:srgbClr val="F59E0B"/>
                 </a:solidFill>
@@ -3955,7 +3955,7 @@
               </a:defRPr>
             </a:pPr>
             <a:r>
-              <a:t>Turning Abstract Cloud Jargon into Confident Exam Readiness for Africa's Next 1 Million Developers</a:t>
+              <a:t>Genuine Exam Preparation Calibrated to Microsoft's Official 700/1000 Passing Standard</a:t>
             </a:r>
           </a:p>
         </p:txBody>
@@ -3969,7 +3969,7 @@
         <p:spPr>
           <a:xfrm>
             <a:off x="731520" y="1920240"/>
-            <a:ext cx="5120640" cy="4114800"/>
+            <a:ext cx="5212080" cy="4297680"/>
           </a:xfrm>
           <a:prstGeom prst="roundRect">
             <a:avLst/>
@@ -4013,8 +4013,8 @@
         </p:nvSpPr>
         <p:spPr>
           <a:xfrm>
-            <a:off x="914400" y="2103120"/>
-            <a:ext cx="4754880" cy="3749039"/>
+            <a:off x="914400" y="2057400"/>
+            <a:ext cx="4846320" cy="3931920"/>
           </a:xfrm>
           <a:prstGeom prst="rect">
             <a:avLst/>
@@ -4028,618 +4028,14 @@
           <a:lstStyle/>
           <a:p>
             <a:pPr>
-              <a:defRPr sz="1600" b="1">
-                <a:solidFill>
-                  <a:srgbClr val="F87171"/>
-                </a:solidFill>
-                <a:latin typeface="Segoe UI"/>
+              <a:defRPr sz="1400" b="1">
+                <a:solidFill>
+                  <a:srgbClr val="38BDF8"/>
+                </a:solidFill>
               </a:defRPr>
             </a:pPr>
             <a:r>
-              <a:t>THE BARRIER: STUDYING BLIND</a:t>
-            </a:r>
-          </a:p>
-          <a:p>
-            <a:pPr>
-              <a:spcBef>
-                <a:spcPts val="1000"/>
-              </a:spcBef>
-              <a:defRPr sz="1200">
-                <a:latin typeface="Segoe UI"/>
-              </a:defRPr>
-            </a:pPr>
-            <a:r>
-              <a:rPr b="1">
-                <a:solidFill>
-                  <a:srgbClr val="F8FAFC"/>
-                </a:solidFill>
-              </a:rPr>
-              <a:t>• High-Stakes Anxiety: </a:t>
-            </a:r>
-            <a:r>
-              <a:rPr>
-                <a:solidFill>
-                  <a:srgbClr val="94A3B8"/>
-                </a:solidFill>
-              </a:rPr>
-              <a:t>$99 certification vouchers expiring in 14 days; learners memorize dumps without knowing if they will pass.</a:t>
-            </a:r>
-          </a:p>
-          <a:p>
-            <a:pPr>
-              <a:spcBef>
-                <a:spcPts val="1000"/>
-              </a:spcBef>
-              <a:defRPr sz="1200">
-                <a:latin typeface="Segoe UI"/>
-              </a:defRPr>
-            </a:pPr>
-            <a:r>
-              <a:rPr b="1">
-                <a:solidFill>
-                  <a:srgbClr val="F8FAFC"/>
-                </a:solidFill>
-              </a:rPr>
-              <a:t>• The 700/1000 Threshold: </a:t>
-            </a:r>
-            <a:r>
-              <a:rPr>
-                <a:solidFill>
-                  <a:srgbClr val="94A3B8"/>
-                </a:solidFill>
-              </a:rPr>
-              <a:t>AZ-900 requires 70% weighted mastery across 3 distinct domains, not a flat test percentage.</a:t>
-            </a:r>
-          </a:p>
-          <a:p>
-            <a:pPr>
-              <a:spcBef>
-                <a:spcPts val="1000"/>
-              </a:spcBef>
-              <a:defRPr sz="1200">
-                <a:latin typeface="Segoe UI"/>
-              </a:defRPr>
-            </a:pPr>
-            <a:r>
-              <a:rPr b="1">
-                <a:solidFill>
-                  <a:srgbClr val="F8FAFC"/>
-                </a:solidFill>
-              </a:rPr>
-              <a:t>• Disconnected Mental Models: </a:t>
-            </a:r>
-            <a:r>
-              <a:rPr>
-                <a:solidFill>
-                  <a:srgbClr val="94A3B8"/>
-                </a:solidFill>
-              </a:rPr>
-              <a:t>Abstract US/EU enterprise analogies (e.g. Wall Street banks) fail to anchor in the daily realities of African students.</a:t>
-            </a:r>
-          </a:p>
-          <a:p>
-            <a:pPr>
-              <a:spcBef>
-                <a:spcPts val="1000"/>
-              </a:spcBef>
-              <a:defRPr sz="1200">
-                <a:latin typeface="Segoe UI"/>
-              </a:defRPr>
-            </a:pPr>
-            <a:r>
-              <a:rPr b="1">
-                <a:solidFill>
-                  <a:srgbClr val="F8FAFC"/>
-                </a:solidFill>
-              </a:rPr>
-              <a:t>• The 'Blind Spot' Trap: </a:t>
-            </a:r>
-            <a:r>
-              <a:rPr>
-                <a:solidFill>
-                  <a:srgbClr val="94A3B8"/>
-                </a:solidFill>
-              </a:rPr>
-              <a:t>Students spend 80% of their revision time on concepts they already know, completely neglecting silent weak points.</a:t>
-            </a:r>
-          </a:p>
-        </p:txBody>
-      </p:sp>
-      <p:sp>
-        <p:nvSpPr>
-          <p:cNvPr id="8" name="Rounded Rectangle 7"/>
-          <p:cNvSpPr/>
-          <p:nvPr/>
-        </p:nvSpPr>
-        <p:spPr>
-          <a:xfrm>
-            <a:off x="6217920" y="1920240"/>
-            <a:ext cx="5212080" cy="4114800"/>
-          </a:xfrm>
-          <a:prstGeom prst="roundRect">
-            <a:avLst/>
-          </a:prstGeom>
-          <a:solidFill>
-            <a:srgbClr val="151E34"/>
-          </a:solidFill>
-          <a:ln w="19050">
-            <a:solidFill>
-              <a:srgbClr val="2D4166"/>
-            </a:solidFill>
-          </a:ln>
-        </p:spPr>
-        <p:style>
-          <a:lnRef idx="1">
-            <a:schemeClr val="accent1"/>
-          </a:lnRef>
-          <a:fillRef idx="3">
-            <a:schemeClr val="accent1"/>
-          </a:fillRef>
-          <a:effectRef idx="2">
-            <a:schemeClr val="accent1"/>
-          </a:effectRef>
-          <a:fontRef idx="minor">
-            <a:schemeClr val="lt1"/>
-          </a:fontRef>
-        </p:style>
-        <p:txBody>
-          <a:bodyPr rtlCol="0" anchor="ctr"/>
-          <a:lstStyle/>
-          <a:p>
-            <a:pPr algn="ctr"/>
-          </a:p>
-        </p:txBody>
-      </p:sp>
-      <p:sp>
-        <p:nvSpPr>
-          <p:cNvPr id="9" name="TextBox 8"/>
-          <p:cNvSpPr txBox="1"/>
-          <p:nvPr/>
-        </p:nvSpPr>
-        <p:spPr>
-          <a:xfrm>
-            <a:off x="6400800" y="2103120"/>
-            <a:ext cx="4846320" cy="3749039"/>
-          </a:xfrm>
-          <a:prstGeom prst="rect">
-            <a:avLst/>
-          </a:prstGeom>
-          <a:noFill/>
-        </p:spPr>
-        <p:txBody>
-          <a:bodyPr wrap="square">
-            <a:spAutoFit/>
-          </a:bodyPr>
-          <a:lstStyle/>
-          <a:p>
-            <a:pPr>
-              <a:defRPr sz="1600" b="1">
-                <a:solidFill>
-                  <a:srgbClr val="38BDF8"/>
-                </a:solidFill>
-                <a:latin typeface="Segoe UI"/>
-              </a:defRPr>
-            </a:pPr>
-            <a:r>
-              <a:t>THE 3 SILENT LEARNING BLINDSPOTS</a:t>
-            </a:r>
-          </a:p>
-          <a:p>
-            <a:pPr>
-              <a:spcBef>
-                <a:spcPts val="1200"/>
-              </a:spcBef>
-              <a:defRPr sz="1200">
-                <a:latin typeface="Segoe UI"/>
-              </a:defRPr>
-            </a:pPr>
-            <a:r>
-              <a:rPr b="1">
-                <a:solidFill>
-                  <a:srgbClr val="F59E0B"/>
-                </a:solidFill>
-              </a:rPr>
-              <a:t>⚠️ 1. Jargon Overload: </a:t>
-            </a:r>
-            <a:r>
-              <a:rPr>
-                <a:solidFill>
-                  <a:srgbClr val="94A3B8"/>
-                </a:solidFill>
-              </a:rPr>
-              <a:t>Terms like 'Availability Zones', 'IaaS vs PaaS', and 'Blob Archive Rehydration' feel completely alien without contextual hooks.</a:t>
-            </a:r>
-          </a:p>
-          <a:p>
-            <a:pPr>
-              <a:spcBef>
-                <a:spcPts val="1200"/>
-              </a:spcBef>
-              <a:defRPr sz="1200">
-                <a:latin typeface="Segoe UI"/>
-              </a:defRPr>
-            </a:pPr>
-            <a:r>
-              <a:rPr b="1">
-                <a:solidFill>
-                  <a:srgbClr val="F59E0B"/>
-                </a:solidFill>
-              </a:rPr>
-              <a:t>⚠️ 2. The 'Why Is This Wrong?' Gap: </a:t>
-            </a:r>
-            <a:r>
-              <a:rPr>
-                <a:solidFill>
-                  <a:srgbClr val="94A3B8"/>
-                </a:solidFill>
-              </a:rPr>
-              <a:t>Standard mock tests tell you option 'A' is correct, but leave you guessing why options 'B, C, and D' fail. Real exam questions test edge cases.</a:t>
-            </a:r>
-          </a:p>
-          <a:p>
-            <a:pPr>
-              <a:spcBef>
-                <a:spcPts val="1200"/>
-              </a:spcBef>
-              <a:defRPr sz="1200">
-                <a:latin typeface="Segoe UI"/>
-              </a:defRPr>
-            </a:pPr>
-            <a:r>
-              <a:rPr b="1">
-                <a:solidFill>
-                  <a:srgbClr val="F59E0B"/>
-                </a:solidFill>
-              </a:rPr>
-              <a:t>⚠️ 3. The Static Percentage Illusion: </a:t>
-            </a:r>
-            <a:r>
-              <a:rPr>
-                <a:solidFill>
-                  <a:srgbClr val="94A3B8"/>
-                </a:solidFill>
-              </a:rPr>
-              <a:t>Scoring 80% on 10 random questions != passing the actual exam. Without domain weighting, students walk into Pearson VUE unprepared.</a:t>
-            </a:r>
-          </a:p>
-        </p:txBody>
-      </p:sp>
-      <p:sp>
-        <p:nvSpPr>
-          <p:cNvPr id="10" name="TextBox 9"/>
-          <p:cNvSpPr txBox="1"/>
-          <p:nvPr/>
-        </p:nvSpPr>
-        <p:spPr>
-          <a:xfrm>
-            <a:off x="731520" y="6217920"/>
-            <a:ext cx="10698480" cy="365760"/>
-          </a:xfrm>
-          <a:prstGeom prst="rect">
-            <a:avLst/>
-          </a:prstGeom>
-          <a:noFill/>
-        </p:spPr>
-        <p:txBody>
-          <a:bodyPr wrap="none">
-            <a:spAutoFit/>
-          </a:bodyPr>
-          <a:lstStyle/>
-          <a:p>
-            <a:pPr algn="ctr">
-              <a:defRPr sz="1000" i="1">
-                <a:solidFill>
-                  <a:srgbClr val="94A3B8"/>
-                </a:solidFill>
-                <a:latin typeface="Segoe UI"/>
-              </a:defRPr>
-            </a:pPr>
-            <a:r>
-              <a:t>🛡️ Community Built for #1MillionDevs | Strictly Unofficial Study Companion Aligned with Public Microsoft Learn Guidelines</a:t>
-            </a:r>
-          </a:p>
-        </p:txBody>
-      </p:sp>
-    </p:spTree>
-  </p:cSld>
-  <p:clrMapOvr>
-    <a:masterClrMapping/>
-  </p:clrMapOvr>
-</p:sld>
-</file>
-
-<file path=ppt/slides/slide2.xml><?xml version="1.0" encoding="utf-8"?>
-<p:sld xmlns:a="http://schemas.openxmlformats.org/drawingml/2006/main" xmlns:p="http://schemas.openxmlformats.org/presentationml/2006/main" xmlns:r="http://schemas.openxmlformats.org/officeDocument/2006/relationships">
-  <p:cSld>
-    <p:spTree>
-      <p:nvGrpSpPr>
-        <p:cNvPr id="1" name=""/>
-        <p:cNvGrpSpPr/>
-        <p:nvPr/>
-      </p:nvGrpSpPr>
-      <p:grpSpPr/>
-      <p:sp>
-        <p:nvSpPr>
-          <p:cNvPr id="2" name="Rectangle 1"/>
-          <p:cNvSpPr/>
-          <p:nvPr/>
-        </p:nvSpPr>
-        <p:spPr>
-          <a:xfrm>
-            <a:off x="0" y="0"/>
-            <a:ext cx="12191695" cy="6858000"/>
-          </a:xfrm>
-          <a:prstGeom prst="rect">
-            <a:avLst/>
-          </a:prstGeom>
-          <a:solidFill>
-            <a:srgbClr val="0A0F1D"/>
-          </a:solidFill>
-          <a:ln>
-            <a:noFill/>
-          </a:ln>
-        </p:spPr>
-        <p:style>
-          <a:lnRef idx="1">
-            <a:schemeClr val="accent1"/>
-          </a:lnRef>
-          <a:fillRef idx="3">
-            <a:schemeClr val="accent1"/>
-          </a:fillRef>
-          <a:effectRef idx="2">
-            <a:schemeClr val="accent1"/>
-          </a:effectRef>
-          <a:fontRef idx="minor">
-            <a:schemeClr val="lt1"/>
-          </a:fontRef>
-        </p:style>
-        <p:txBody>
-          <a:bodyPr rtlCol="0" anchor="ctr"/>
-          <a:lstStyle/>
-          <a:p>
-            <a:pPr algn="ctr"/>
-          </a:p>
-        </p:txBody>
-      </p:sp>
-      <p:sp>
-        <p:nvSpPr>
-          <p:cNvPr id="3" name="Rounded Rectangle 2"/>
-          <p:cNvSpPr/>
-          <p:nvPr/>
-        </p:nvSpPr>
-        <p:spPr>
-          <a:xfrm>
-            <a:off x="731520" y="365760"/>
-            <a:ext cx="4206240" cy="320040"/>
-          </a:xfrm>
-          <a:prstGeom prst="roundRect">
-            <a:avLst/>
-          </a:prstGeom>
-          <a:solidFill>
-            <a:srgbClr val="1E293B"/>
-          </a:solidFill>
-          <a:ln>
-            <a:noFill/>
-          </a:ln>
-        </p:spPr>
-        <p:style>
-          <a:lnRef idx="1">
-            <a:schemeClr val="accent1"/>
-          </a:lnRef>
-          <a:fillRef idx="3">
-            <a:schemeClr val="accent1"/>
-          </a:fillRef>
-          <a:effectRef idx="2">
-            <a:schemeClr val="accent1"/>
-          </a:effectRef>
-          <a:fontRef idx="minor">
-            <a:schemeClr val="lt1"/>
-          </a:fontRef>
-        </p:style>
-        <p:txBody>
-          <a:bodyPr rtlCol="0" anchor="ctr"/>
-          <a:lstStyle/>
-          <a:p>
-            <a:pPr algn="ctr">
-              <a:defRPr sz="1000" b="1">
-                <a:solidFill>
-                  <a:srgbClr val="38BDF8"/>
-                </a:solidFill>
-                <a:latin typeface="Segoe UI"/>
-              </a:defRPr>
-            </a:pPr>
-            <a:r>
-              <a:t>SOLUTION ARCHITECTURE &amp; LIVE PRODUCT DEMO  |  RUBRIC: 25 PTS</a:t>
-            </a:r>
-          </a:p>
-        </p:txBody>
-      </p:sp>
-      <p:sp>
-        <p:nvSpPr>
-          <p:cNvPr id="4" name="TextBox 3"/>
-          <p:cNvSpPr txBox="1"/>
-          <p:nvPr/>
-        </p:nvSpPr>
-        <p:spPr>
-          <a:xfrm>
-            <a:off x="731520" y="749808"/>
-            <a:ext cx="10698480" cy="594360"/>
-          </a:xfrm>
-          <a:prstGeom prst="rect">
-            <a:avLst/>
-          </a:prstGeom>
-          <a:noFill/>
-        </p:spPr>
-        <p:txBody>
-          <a:bodyPr wrap="square">
-            <a:spAutoFit/>
-          </a:bodyPr>
-          <a:lstStyle/>
-          <a:p>
-            <a:pPr>
-              <a:defRPr sz="2400" b="1">
-                <a:solidFill>
-                  <a:srgbClr val="F8FAFC"/>
-                </a:solidFill>
-                <a:latin typeface="Segoe UI"/>
-              </a:defRPr>
-            </a:pPr>
-            <a:r>
-              <a:t>The Cognitive Readiness Engine &amp; Progressive Mastery Loop</a:t>
-            </a:r>
-          </a:p>
-        </p:txBody>
-      </p:sp>
-      <p:sp>
-        <p:nvSpPr>
-          <p:cNvPr id="5" name="TextBox 4"/>
-          <p:cNvSpPr txBox="1"/>
-          <p:nvPr/>
-        </p:nvSpPr>
-        <p:spPr>
-          <a:xfrm>
-            <a:off x="731520" y="1325880"/>
-            <a:ext cx="10698480" cy="411480"/>
-          </a:xfrm>
-          <a:prstGeom prst="rect">
-            <a:avLst/>
-          </a:prstGeom>
-          <a:noFill/>
-        </p:spPr>
-        <p:txBody>
-          <a:bodyPr wrap="square">
-            <a:spAutoFit/>
-          </a:bodyPr>
-          <a:lstStyle/>
-          <a:p>
-            <a:pPr>
-              <a:defRPr sz="1300" i="1">
-                <a:solidFill>
-                  <a:srgbClr val="F59E0B"/>
-                </a:solidFill>
-                <a:latin typeface="Segoe UI"/>
-              </a:defRPr>
-            </a:pPr>
-            <a:r>
-              <a:t>Real-Time Weighted Exam Modeling With Automated Weak Area Pitstops</a:t>
-            </a:r>
-          </a:p>
-        </p:txBody>
-      </p:sp>
-      <p:sp>
-        <p:nvSpPr>
-          <p:cNvPr id="6" name="Rounded Rectangle 5"/>
-          <p:cNvSpPr/>
-          <p:nvPr/>
-        </p:nvSpPr>
-        <p:spPr>
-          <a:xfrm>
-            <a:off x="731520" y="1920240"/>
-            <a:ext cx="3383280" cy="4297680"/>
-          </a:xfrm>
-          <a:prstGeom prst="roundRect">
-            <a:avLst/>
-          </a:prstGeom>
-          <a:solidFill>
-            <a:srgbClr val="151E34"/>
-          </a:solidFill>
-          <a:ln w="19050">
-            <a:solidFill>
-              <a:srgbClr val="2D4166"/>
-            </a:solidFill>
-          </a:ln>
-        </p:spPr>
-        <p:style>
-          <a:lnRef idx="1">
-            <a:schemeClr val="accent1"/>
-          </a:lnRef>
-          <a:fillRef idx="3">
-            <a:schemeClr val="accent1"/>
-          </a:fillRef>
-          <a:effectRef idx="2">
-            <a:schemeClr val="accent1"/>
-          </a:effectRef>
-          <a:fontRef idx="minor">
-            <a:schemeClr val="lt1"/>
-          </a:fontRef>
-        </p:style>
-        <p:txBody>
-          <a:bodyPr rtlCol="0" anchor="ctr"/>
-          <a:lstStyle/>
-          <a:p>
-            <a:pPr algn="ctr"/>
-          </a:p>
-        </p:txBody>
-      </p:sp>
-      <p:sp>
-        <p:nvSpPr>
-          <p:cNvPr id="7" name="TextBox 6"/>
-          <p:cNvSpPr txBox="1"/>
-          <p:nvPr/>
-        </p:nvSpPr>
-        <p:spPr>
-          <a:xfrm>
-            <a:off x="868680" y="2103120"/>
-            <a:ext cx="3108960" cy="3931920"/>
-          </a:xfrm>
-          <a:prstGeom prst="rect">
-            <a:avLst/>
-          </a:prstGeom>
-          <a:noFill/>
-        </p:spPr>
-        <p:txBody>
-          <a:bodyPr wrap="square">
-            <a:spAutoFit/>
-          </a:bodyPr>
-          <a:lstStyle/>
-          <a:p>
-            <a:pPr>
-              <a:defRPr sz="1400" b="1">
-                <a:solidFill>
-                  <a:srgbClr val="38BDF8"/>
-                </a:solidFill>
-              </a:defRPr>
-            </a:pPr>
-            <a:r>
-              <a:t>1. MULTI-SIGNAL READINESS</a:t>
-            </a:r>
-          </a:p>
-          <a:p>
-            <a:pPr>
-              <a:spcBef>
-                <a:spcPts val="800"/>
-              </a:spcBef>
-              <a:defRPr sz="1100" b="1">
-                <a:solidFill>
-                  <a:srgbClr val="F8FAFC"/>
-                </a:solidFill>
-              </a:defRPr>
-            </a:pPr>
-            <a:r>
-              <a:t>Mathematical Syllabus Weighting:</a:t>
-            </a:r>
-          </a:p>
-          <a:p>
-            <a:pPr>
-              <a:spcBef>
-                <a:spcPts val="400"/>
-              </a:spcBef>
-              <a:defRPr sz="1100" b="1">
-                <a:solidFill>
-                  <a:srgbClr val="F59E0B"/>
-                </a:solidFill>
-              </a:defRPr>
-            </a:pPr>
-            <a:r>
-              <a:t>R_exam = 27.5% · Concepts</a:t>
-            </a:r>
-            <a:br/>
-            <a:r>
-              <a:t>       + 37.5% · Architecture</a:t>
-            </a:r>
-            <a:br/>
-            <a:r>
-              <a:t>       + 35.0% · Governance</a:t>
+              <a:t>OFFICIAL SYLLABUS CALIBRATION</a:t>
             </a:r>
           </a:p>
           <a:p>
@@ -4655,7 +4051,7 @@
                   <a:srgbClr val="F8FAFC"/>
                 </a:solidFill>
               </a:rPr>
-              <a:t>• Dynamic Passing Probability: </a:t>
+              <a:t>• Strict Microsoft Learn Alignment: </a:t>
             </a:r>
             <a:r>
               <a:rPr>
@@ -4663,7 +4059,7 @@
                   <a:srgbClr val="94A3B8"/>
                 </a:solidFill>
               </a:rPr>
-              <a:t>Calibrates test-readiness vs. the official 700/1000 passing mark.</a:t>
+              <a:t>Covers all 3 official core exam domains: Cloud Concepts (27.5%), Architecture &amp; Services (37.5%), and Management &amp; Governance (35.0%).</a:t>
             </a:r>
           </a:p>
           <a:p>
@@ -4679,7 +4075,7 @@
                   <a:srgbClr val="F8FAFC"/>
                 </a:solidFill>
               </a:rPr>
-              <a:t>• Weakness Radar (&lt;70%): </a:t>
+              <a:t>• Mathematical Readiness Modeling: </a:t>
             </a:r>
             <a:r>
               <a:rPr>
@@ -4687,7 +4083,7 @@
                   <a:srgbClr val="94A3B8"/>
                 </a:solidFill>
               </a:rPr>
-              <a:t>Instantly identifies failing subtopics (e.g. Azure Networking at 0%).</a:t>
+              <a:t>Instead of a naive quiz percentage, we calculate: R_exam = 0.275·C + 0.375·A + 0.35·G, mirroring Pearson VUE's actual 700/1000 passing threshold.</a:t>
             </a:r>
           </a:p>
           <a:p>
@@ -4703,7 +4099,7 @@
                   <a:srgbClr val="F8FAFC"/>
                 </a:solidFill>
               </a:rPr>
-              <a:t>• Baseline Self-Assessment: </a:t>
+              <a:t>• 30-Second Baseline Diagnostic: </a:t>
             </a:r>
             <a:r>
               <a:rPr>
@@ -4711,87 +4107,7 @@
                   <a:srgbClr val="94A3B8"/>
                 </a:solidFill>
               </a:rPr>
-              <a:t>30-second onboarding diagnostic immediately tailors initial path.</a:t>
-            </a:r>
-          </a:p>
-        </p:txBody>
-      </p:sp>
-      <p:sp>
-        <p:nvSpPr>
-          <p:cNvPr id="8" name="Rounded Rectangle 7"/>
-          <p:cNvSpPr/>
-          <p:nvPr/>
-        </p:nvSpPr>
-        <p:spPr>
-          <a:xfrm>
-            <a:off x="4389120" y="1920240"/>
-            <a:ext cx="3383280" cy="4297680"/>
-          </a:xfrm>
-          <a:prstGeom prst="roundRect">
-            <a:avLst/>
-          </a:prstGeom>
-          <a:solidFill>
-            <a:srgbClr val="151E34"/>
-          </a:solidFill>
-          <a:ln w="19050">
-            <a:solidFill>
-              <a:srgbClr val="2D4166"/>
-            </a:solidFill>
-          </a:ln>
-        </p:spPr>
-        <p:style>
-          <a:lnRef idx="1">
-            <a:schemeClr val="accent1"/>
-          </a:lnRef>
-          <a:fillRef idx="3">
-            <a:schemeClr val="accent1"/>
-          </a:fillRef>
-          <a:effectRef idx="2">
-            <a:schemeClr val="accent1"/>
-          </a:effectRef>
-          <a:fontRef idx="minor">
-            <a:schemeClr val="lt1"/>
-          </a:fontRef>
-        </p:style>
-        <p:txBody>
-          <a:bodyPr rtlCol="0" anchor="ctr"/>
-          <a:lstStyle/>
-          <a:p>
-            <a:pPr algn="ctr"/>
-          </a:p>
-        </p:txBody>
-      </p:sp>
-      <p:sp>
-        <p:nvSpPr>
-          <p:cNvPr id="9" name="TextBox 8"/>
-          <p:cNvSpPr txBox="1"/>
-          <p:nvPr/>
-        </p:nvSpPr>
-        <p:spPr>
-          <a:xfrm>
-            <a:off x="4526280" y="2103120"/>
-            <a:ext cx="3108960" cy="3931920"/>
-          </a:xfrm>
-          <a:prstGeom prst="rect">
-            <a:avLst/>
-          </a:prstGeom>
-          <a:noFill/>
-        </p:spPr>
-        <p:txBody>
-          <a:bodyPr wrap="square">
-            <a:spAutoFit/>
-          </a:bodyPr>
-          <a:lstStyle/>
-          <a:p>
-            <a:pPr>
-              <a:defRPr sz="1400" b="1">
-                <a:solidFill>
-                  <a:srgbClr val="10B981"/>
-                </a:solidFill>
-              </a:defRPr>
-            </a:pPr>
-            <a:r>
-              <a:t>2. PROGRESSIVE MASTER LOOP</a:t>
+              <a:t>Onboarding assessment instantly classifies learners (Novice vs. Intermediate) and generates a tailored study plan.</a:t>
             </a:r>
           </a:p>
           <a:p>
@@ -4804,11 +4120,10 @@
             <a:r>
               <a:rPr b="1">
                 <a:solidFill>
-                  <a:srgbClr val="F59E0B"/>
-                </a:solidFill>
-              </a:rPr>
-              <a:t>✓ Step 1: Explore &amp; Learn
-</a:t>
+                  <a:srgbClr val="F8FAFC"/>
+                </a:solidFill>
+              </a:rPr>
+              <a:t>• Eliminating Voucher Waste: </a:t>
             </a:r>
             <a:r>
               <a:rPr>
@@ -4816,1425 +4131,7 @@
                   <a:srgbClr val="94A3B8"/>
                 </a:solidFill>
               </a:rPr>
-              <a:t>Personalized to learning style (Visual architecture diagram, African analogy, or Kinesthetic CLI command).</a:t>
-            </a:r>
-          </a:p>
-          <a:p>
-            <a:pPr>
-              <a:spcBef>
-                <a:spcPts val="800"/>
-              </a:spcBef>
-              <a:defRPr sz="1050"/>
-            </a:pPr>
-            <a:r>
-              <a:rPr b="1">
-                <a:solidFill>
-                  <a:srgbClr val="F59E0B"/>
-                </a:solidFill>
-              </a:rPr>
-              <a:t>✓ Step 2: Practice Checkpoint
-</a:t>
-            </a:r>
-            <a:r>
-              <a:rPr>
-                <a:solidFill>
-                  <a:srgbClr val="94A3B8"/>
-                </a:solidFill>
-              </a:rPr>
-              <a:t>Scenario questions with instant distractor feedback explaining exactly WHY the other 3 choices fail.</a:t>
-            </a:r>
-          </a:p>
-          <a:p>
-            <a:pPr>
-              <a:spcBef>
-                <a:spcPts val="800"/>
-              </a:spcBef>
-              <a:defRPr sz="1050"/>
-            </a:pPr>
-            <a:r>
-              <a:rPr b="1">
-                <a:solidFill>
-                  <a:srgbClr val="F59E0B"/>
-                </a:solidFill>
-              </a:rPr>
-              <a:t>✓ Step 3: Memory Lock
-</a:t>
-            </a:r>
-            <a:r>
-              <a:rPr>
-                <a:solidFill>
-                  <a:srgbClr val="94A3B8"/>
-                </a:solidFill>
-              </a:rPr>
-              <a:t>Active recall spaced-repetition flashcards lock in key concepts.</a:t>
-            </a:r>
-          </a:p>
-          <a:p>
-            <a:pPr>
-              <a:spcBef>
-                <a:spcPts val="800"/>
-              </a:spcBef>
-              <a:defRPr sz="1050"/>
-            </a:pPr>
-            <a:r>
-              <a:rPr b="1">
-                <a:solidFill>
-                  <a:srgbClr val="F59E0B"/>
-                </a:solidFill>
-              </a:rPr>
-              <a:t>✓ Step 4: Weakness Pitstop
-</a:t>
-            </a:r>
-            <a:r>
-              <a:rPr>
-                <a:solidFill>
-                  <a:srgbClr val="94A3B8"/>
-                </a:solidFill>
-              </a:rPr>
-              <a:t>Closed loop automatically inserts remedial missions for any subtopic scoring below 70%.</a:t>
-            </a:r>
-          </a:p>
-        </p:txBody>
-      </p:sp>
-      <p:sp>
-        <p:nvSpPr>
-          <p:cNvPr id="10" name="Rounded Rectangle 9"/>
-          <p:cNvSpPr/>
-          <p:nvPr/>
-        </p:nvSpPr>
-        <p:spPr>
-          <a:xfrm>
-            <a:off x="8046720" y="1920240"/>
-            <a:ext cx="3383280" cy="4297680"/>
-          </a:xfrm>
-          <a:prstGeom prst="roundRect">
-            <a:avLst/>
-          </a:prstGeom>
-          <a:solidFill>
-            <a:srgbClr val="151E34"/>
-          </a:solidFill>
-          <a:ln w="19050">
-            <a:solidFill>
-              <a:srgbClr val="2D4166"/>
-            </a:solidFill>
-          </a:ln>
-        </p:spPr>
-        <p:style>
-          <a:lnRef idx="1">
-            <a:schemeClr val="accent1"/>
-          </a:lnRef>
-          <a:fillRef idx="3">
-            <a:schemeClr val="accent1"/>
-          </a:fillRef>
-          <a:effectRef idx="2">
-            <a:schemeClr val="accent1"/>
-          </a:effectRef>
-          <a:fontRef idx="minor">
-            <a:schemeClr val="lt1"/>
-          </a:fontRef>
-        </p:style>
-        <p:txBody>
-          <a:bodyPr rtlCol="0" anchor="ctr"/>
-          <a:lstStyle/>
-          <a:p>
-            <a:pPr algn="ctr"/>
-          </a:p>
-        </p:txBody>
-      </p:sp>
-      <p:sp>
-        <p:nvSpPr>
-          <p:cNvPr id="11" name="TextBox 10"/>
-          <p:cNvSpPr txBox="1"/>
-          <p:nvPr/>
-        </p:nvSpPr>
-        <p:spPr>
-          <a:xfrm>
-            <a:off x="8183880" y="2103120"/>
-            <a:ext cx="3108960" cy="3931920"/>
-          </a:xfrm>
-          <a:prstGeom prst="rect">
-            <a:avLst/>
-          </a:prstGeom>
-          <a:noFill/>
-        </p:spPr>
-        <p:txBody>
-          <a:bodyPr wrap="square">
-            <a:spAutoFit/>
-          </a:bodyPr>
-          <a:lstStyle/>
-          <a:p>
-            <a:pPr>
-              <a:defRPr sz="1400" b="1">
-                <a:solidFill>
-                  <a:srgbClr val="F59E0B"/>
-                </a:solidFill>
-              </a:defRPr>
-            </a:pPr>
-            <a:r>
-              <a:t>3. OFFLINE PWA &amp; SMART SPRINT</a:t>
-            </a:r>
-          </a:p>
-          <a:p>
-            <a:pPr>
-              <a:spcBef>
-                <a:spcPts val="800"/>
-              </a:spcBef>
-              <a:defRPr sz="1050"/>
-            </a:pPr>
-            <a:r>
-              <a:rPr b="1">
-                <a:solidFill>
-                  <a:srgbClr val="F8FAFC"/>
-                </a:solidFill>
-              </a:rPr>
-              <a:t>⚡ Zero-Data Service Worker: </a:t>
-            </a:r>
-            <a:r>
-              <a:rPr>
-                <a:solidFill>
-                  <a:srgbClr val="94A3B8"/>
-                </a:solidFill>
-              </a:rPr>
-              <a:t>Runs 100% client-side via sw.js. Works in airplane mode or during load-shedding blackouts.</a:t>
-            </a:r>
-          </a:p>
-          <a:p>
-            <a:pPr>
-              <a:spcBef>
-                <a:spcPts val="800"/>
-              </a:spcBef>
-              <a:defRPr sz="1050"/>
-            </a:pPr>
-            <a:r>
-              <a:rPr b="1">
-                <a:solidFill>
-                  <a:srgbClr val="F8FAFC"/>
-                </a:solidFill>
-              </a:rPr>
-              <a:t>⚡ Background Revision Alarm: </a:t>
-            </a:r>
-            <a:r>
-              <a:rPr>
-                <a:solidFill>
-                  <a:srgbClr val="94A3B8"/>
-                </a:solidFill>
-              </a:rPr>
-              <a:t>Schedules offline browser study reminders that trigger even when internet is disconnected.</a:t>
-            </a:r>
-          </a:p>
-          <a:p>
-            <a:pPr>
-              <a:spcBef>
-                <a:spcPts val="800"/>
-              </a:spcBef>
-              <a:defRPr sz="1050"/>
-            </a:pPr>
-            <a:r>
-              <a:rPr b="1">
-                <a:solidFill>
-                  <a:srgbClr val="F8FAFC"/>
-                </a:solidFill>
-              </a:rPr>
-              <a:t>⚡ Adaptive Sprint Planner: </a:t>
-            </a:r>
-            <a:r>
-              <a:rPr>
-                <a:solidFill>
-                  <a:srgbClr val="94A3B8"/>
-                </a:solidFill>
-              </a:rPr>
-              <a:t>Calculates daily study minutes needed based on target exam date and current readiness score.</a:t>
-            </a:r>
-          </a:p>
-          <a:p>
-            <a:pPr>
-              <a:spcBef>
-                <a:spcPts val="800"/>
-              </a:spcBef>
-              <a:defRPr sz="1050"/>
-            </a:pPr>
-            <a:r>
-              <a:rPr b="1">
-                <a:solidFill>
-                  <a:srgbClr val="F8FAFC"/>
-                </a:solidFill>
-              </a:rPr>
-              <a:t>⚡ Persistent Local Storage: </a:t>
-            </a:r>
-            <a:r>
-              <a:rPr>
-                <a:solidFill>
-                  <a:srgbClr val="94A3B8"/>
-                </a:solidFill>
-              </a:rPr>
-              <a:t>Progress, quiz answers, and flashcard masteries are preserved securely with zero login friction.</a:t>
-            </a:r>
-          </a:p>
-        </p:txBody>
-      </p:sp>
-    </p:spTree>
-  </p:cSld>
-  <p:clrMapOvr>
-    <a:masterClrMapping/>
-  </p:clrMapOvr>
-</p:sld>
-</file>
-
-<file path=ppt/slides/slide3.xml><?xml version="1.0" encoding="utf-8"?>
-<p:sld xmlns:a="http://schemas.openxmlformats.org/drawingml/2006/main" xmlns:p="http://schemas.openxmlformats.org/presentationml/2006/main" xmlns:r="http://schemas.openxmlformats.org/officeDocument/2006/relationships">
-  <p:cSld>
-    <p:spTree>
-      <p:nvGrpSpPr>
-        <p:cNvPr id="1" name=""/>
-        <p:cNvGrpSpPr/>
-        <p:nvPr/>
-      </p:nvGrpSpPr>
-      <p:grpSpPr/>
-      <p:sp>
-        <p:nvSpPr>
-          <p:cNvPr id="2" name="Rectangle 1"/>
-          <p:cNvSpPr/>
-          <p:nvPr/>
-        </p:nvSpPr>
-        <p:spPr>
-          <a:xfrm>
-            <a:off x="0" y="0"/>
-            <a:ext cx="12191695" cy="6858000"/>
-          </a:xfrm>
-          <a:prstGeom prst="rect">
-            <a:avLst/>
-          </a:prstGeom>
-          <a:solidFill>
-            <a:srgbClr val="0A0F1D"/>
-          </a:solidFill>
-          <a:ln>
-            <a:noFill/>
-          </a:ln>
-        </p:spPr>
-        <p:style>
-          <a:lnRef idx="1">
-            <a:schemeClr val="accent1"/>
-          </a:lnRef>
-          <a:fillRef idx="3">
-            <a:schemeClr val="accent1"/>
-          </a:fillRef>
-          <a:effectRef idx="2">
-            <a:schemeClr val="accent1"/>
-          </a:effectRef>
-          <a:fontRef idx="minor">
-            <a:schemeClr val="lt1"/>
-          </a:fontRef>
-        </p:style>
-        <p:txBody>
-          <a:bodyPr rtlCol="0" anchor="ctr"/>
-          <a:lstStyle/>
-          <a:p>
-            <a:pPr algn="ctr"/>
-          </a:p>
-        </p:txBody>
-      </p:sp>
-      <p:sp>
-        <p:nvSpPr>
-          <p:cNvPr id="3" name="Rounded Rectangle 2"/>
-          <p:cNvSpPr/>
-          <p:nvPr/>
-        </p:nvSpPr>
-        <p:spPr>
-          <a:xfrm>
-            <a:off x="731520" y="365760"/>
-            <a:ext cx="4206240" cy="320040"/>
-          </a:xfrm>
-          <a:prstGeom prst="roundRect">
-            <a:avLst/>
-          </a:prstGeom>
-          <a:solidFill>
-            <a:srgbClr val="1E293B"/>
-          </a:solidFill>
-          <a:ln>
-            <a:noFill/>
-          </a:ln>
-        </p:spPr>
-        <p:style>
-          <a:lnRef idx="1">
-            <a:schemeClr val="accent1"/>
-          </a:lnRef>
-          <a:fillRef idx="3">
-            <a:schemeClr val="accent1"/>
-          </a:fillRef>
-          <a:effectRef idx="2">
-            <a:schemeClr val="accent1"/>
-          </a:effectRef>
-          <a:fontRef idx="minor">
-            <a:schemeClr val="lt1"/>
-          </a:fontRef>
-        </p:style>
-        <p:txBody>
-          <a:bodyPr rtlCol="0" anchor="ctr"/>
-          <a:lstStyle/>
-          <a:p>
-            <a:pPr algn="ctr">
-              <a:defRPr sz="1000" b="1">
-                <a:solidFill>
-                  <a:srgbClr val="38BDF8"/>
-                </a:solidFill>
-                <a:latin typeface="Segoe UI"/>
-              </a:defRPr>
-            </a:pPr>
-            <a:r>
-              <a:t>TARGET USERS &amp; LOCALIZED PEDAGOGY  |  RUBRIC: 15 PTS</a:t>
-            </a:r>
-          </a:p>
-        </p:txBody>
-      </p:sp>
-      <p:sp>
-        <p:nvSpPr>
-          <p:cNvPr id="4" name="TextBox 3"/>
-          <p:cNvSpPr txBox="1"/>
-          <p:nvPr/>
-        </p:nvSpPr>
-        <p:spPr>
-          <a:xfrm>
-            <a:off x="731520" y="749808"/>
-            <a:ext cx="10698480" cy="594360"/>
-          </a:xfrm>
-          <a:prstGeom prst="rect">
-            <a:avLst/>
-          </a:prstGeom>
-          <a:noFill/>
-        </p:spPr>
-        <p:txBody>
-          <a:bodyPr wrap="square">
-            <a:spAutoFit/>
-          </a:bodyPr>
-          <a:lstStyle/>
-          <a:p>
-            <a:pPr>
-              <a:defRPr sz="2400" b="1">
-                <a:solidFill>
-                  <a:srgbClr val="F8FAFC"/>
-                </a:solidFill>
-                <a:latin typeface="Segoe UI"/>
-              </a:defRPr>
-            </a:pPr>
-            <a:r>
-              <a:t>Designed for the Real Realities of 1 Million African Developers</a:t>
-            </a:r>
-          </a:p>
-        </p:txBody>
-      </p:sp>
-      <p:sp>
-        <p:nvSpPr>
-          <p:cNvPr id="5" name="TextBox 4"/>
-          <p:cNvSpPr txBox="1"/>
-          <p:nvPr/>
-        </p:nvSpPr>
-        <p:spPr>
-          <a:xfrm>
-            <a:off x="731520" y="1325880"/>
-            <a:ext cx="10698480" cy="411480"/>
-          </a:xfrm>
-          <a:prstGeom prst="rect">
-            <a:avLst/>
-          </a:prstGeom>
-          <a:noFill/>
-        </p:spPr>
-        <p:txBody>
-          <a:bodyPr wrap="square">
-            <a:spAutoFit/>
-          </a:bodyPr>
-          <a:lstStyle/>
-          <a:p>
-            <a:pPr>
-              <a:defRPr sz="1300" i="1">
-                <a:solidFill>
-                  <a:srgbClr val="F59E0B"/>
-                </a:solidFill>
-                <a:latin typeface="Segoe UI"/>
-              </a:defRPr>
-            </a:pPr>
-            <a:r>
-              <a:t>Bridging High-Tech Cloud Concepts With Relatable Mental Models &amp; Multilingual Context</a:t>
-            </a:r>
-          </a:p>
-        </p:txBody>
-      </p:sp>
-      <p:sp>
-        <p:nvSpPr>
-          <p:cNvPr id="6" name="Rounded Rectangle 5"/>
-          <p:cNvSpPr/>
-          <p:nvPr/>
-        </p:nvSpPr>
-        <p:spPr>
-          <a:xfrm>
-            <a:off x="731520" y="1920240"/>
-            <a:ext cx="3383280" cy="3200400"/>
-          </a:xfrm>
-          <a:prstGeom prst="roundRect">
-            <a:avLst/>
-          </a:prstGeom>
-          <a:solidFill>
-            <a:srgbClr val="151E34"/>
-          </a:solidFill>
-          <a:ln w="19050">
-            <a:solidFill>
-              <a:srgbClr val="2D4166"/>
-            </a:solidFill>
-          </a:ln>
-        </p:spPr>
-        <p:style>
-          <a:lnRef idx="1">
-            <a:schemeClr val="accent1"/>
-          </a:lnRef>
-          <a:fillRef idx="3">
-            <a:schemeClr val="accent1"/>
-          </a:fillRef>
-          <a:effectRef idx="2">
-            <a:schemeClr val="accent1"/>
-          </a:effectRef>
-          <a:fontRef idx="minor">
-            <a:schemeClr val="lt1"/>
-          </a:fontRef>
-        </p:style>
-        <p:txBody>
-          <a:bodyPr rtlCol="0" anchor="ctr"/>
-          <a:lstStyle/>
-          <a:p>
-            <a:pPr algn="ctr"/>
-          </a:p>
-        </p:txBody>
-      </p:sp>
-      <p:sp>
-        <p:nvSpPr>
-          <p:cNvPr id="7" name="TextBox 6"/>
-          <p:cNvSpPr txBox="1"/>
-          <p:nvPr/>
-        </p:nvSpPr>
-        <p:spPr>
-          <a:xfrm>
-            <a:off x="868680" y="2057400"/>
-            <a:ext cx="3108960" cy="2926080"/>
-          </a:xfrm>
-          <a:prstGeom prst="rect">
-            <a:avLst/>
-          </a:prstGeom>
-          <a:noFill/>
-        </p:spPr>
-        <p:txBody>
-          <a:bodyPr wrap="square">
-            <a:spAutoFit/>
-          </a:bodyPr>
-          <a:lstStyle/>
-          <a:p>
-            <a:pPr>
-              <a:defRPr sz="1300" b="1">
-                <a:solidFill>
-                  <a:srgbClr val="38BDF8"/>
-                </a:solidFill>
-              </a:defRPr>
-            </a:pPr>
-            <a:r>
-              <a:t>Amina (University Student)</a:t>
-            </a:r>
-          </a:p>
-          <a:p>
-            <a:pPr>
-              <a:defRPr sz="1000">
-                <a:solidFill>
-                  <a:srgbClr val="94A3B8"/>
-                </a:solidFill>
-              </a:defRPr>
-            </a:pPr>
-            <a:r>
-              <a:t>📍 Nairobi, Kenya</a:t>
-            </a:r>
-          </a:p>
-          <a:p>
-            <a:pPr>
-              <a:spcBef>
-                <a:spcPts val="600"/>
-              </a:spcBef>
-              <a:defRPr sz="1000"/>
-            </a:pPr>
-            <a:r>
-              <a:rPr b="1">
-                <a:solidFill>
-                  <a:srgbClr val="F8FAFC"/>
-                </a:solidFill>
-              </a:rPr>
-              <a:t>Challenge: </a:t>
-            </a:r>
-            <a:r>
-              <a:rPr>
-                <a:solidFill>
-                  <a:srgbClr val="94A3B8"/>
-                </a:solidFill>
-              </a:rPr>
-              <a:t>Studying for first cloud credential on mobile phone. US corporate banking analogies felt abstract.</a:t>
-            </a:r>
-          </a:p>
-          <a:p>
-            <a:pPr>
-              <a:spcBef>
-                <a:spcPts val="600"/>
-              </a:spcBef>
-              <a:defRPr sz="1000"/>
-            </a:pPr>
-            <a:r>
-              <a:rPr b="1">
-                <a:solidFill>
-                  <a:srgbClr val="F8FAFC"/>
-                </a:solidFill>
-              </a:rPr>
-              <a:t>The Hook: </a:t>
-            </a:r>
-            <a:r>
-              <a:rPr>
-                <a:solidFill>
-                  <a:srgbClr val="94A3B8"/>
-                </a:solidFill>
-              </a:rPr>
-              <a:t>Understood High Availability through M-Pesa multi-agent float balancing and redundancy across regions.</a:t>
-            </a:r>
-          </a:p>
-          <a:p>
-            <a:pPr>
-              <a:spcBef>
-                <a:spcPts val="600"/>
-              </a:spcBef>
-              <a:defRPr sz="1000"/>
-            </a:pPr>
-            <a:r>
-              <a:rPr b="1">
-                <a:solidFill>
-                  <a:srgbClr val="F8FAFC"/>
-                </a:solidFill>
-              </a:rPr>
-              <a:t>Outcome: </a:t>
-            </a:r>
-            <a:r>
-              <a:rPr>
-                <a:solidFill>
-                  <a:srgbClr val="94A3B8"/>
-                </a:solidFill>
-              </a:rPr>
-              <a:t>Passed diagnostic checkpoint in 12 minutes.</a:t>
-            </a:r>
-          </a:p>
-        </p:txBody>
-      </p:sp>
-      <p:sp>
-        <p:nvSpPr>
-          <p:cNvPr id="8" name="Rounded Rectangle 7"/>
-          <p:cNvSpPr/>
-          <p:nvPr/>
-        </p:nvSpPr>
-        <p:spPr>
-          <a:xfrm>
-            <a:off x="4389120" y="1920240"/>
-            <a:ext cx="3383280" cy="3200400"/>
-          </a:xfrm>
-          <a:prstGeom prst="roundRect">
-            <a:avLst/>
-          </a:prstGeom>
-          <a:solidFill>
-            <a:srgbClr val="151E34"/>
-          </a:solidFill>
-          <a:ln w="19050">
-            <a:solidFill>
-              <a:srgbClr val="2D4166"/>
-            </a:solidFill>
-          </a:ln>
-        </p:spPr>
-        <p:style>
-          <a:lnRef idx="1">
-            <a:schemeClr val="accent1"/>
-          </a:lnRef>
-          <a:fillRef idx="3">
-            <a:schemeClr val="accent1"/>
-          </a:fillRef>
-          <a:effectRef idx="2">
-            <a:schemeClr val="accent1"/>
-          </a:effectRef>
-          <a:fontRef idx="minor">
-            <a:schemeClr val="lt1"/>
-          </a:fontRef>
-        </p:style>
-        <p:txBody>
-          <a:bodyPr rtlCol="0" anchor="ctr"/>
-          <a:lstStyle/>
-          <a:p>
-            <a:pPr algn="ctr"/>
-          </a:p>
-        </p:txBody>
-      </p:sp>
-      <p:sp>
-        <p:nvSpPr>
-          <p:cNvPr id="9" name="TextBox 8"/>
-          <p:cNvSpPr txBox="1"/>
-          <p:nvPr/>
-        </p:nvSpPr>
-        <p:spPr>
-          <a:xfrm>
-            <a:off x="4526280" y="2057400"/>
-            <a:ext cx="3108960" cy="2926080"/>
-          </a:xfrm>
-          <a:prstGeom prst="rect">
-            <a:avLst/>
-          </a:prstGeom>
-          <a:noFill/>
-        </p:spPr>
-        <p:txBody>
-          <a:bodyPr wrap="square">
-            <a:spAutoFit/>
-          </a:bodyPr>
-          <a:lstStyle/>
-          <a:p>
-            <a:pPr>
-              <a:defRPr sz="1300" b="1">
-                <a:solidFill>
-                  <a:srgbClr val="F59E0B"/>
-                </a:solidFill>
-              </a:defRPr>
-            </a:pPr>
-            <a:r>
-              <a:t>Tunde (Junior Developer)</a:t>
-            </a:r>
-          </a:p>
-          <a:p>
-            <a:pPr>
-              <a:defRPr sz="1000">
-                <a:solidFill>
-                  <a:srgbClr val="94A3B8"/>
-                </a:solidFill>
-              </a:defRPr>
-            </a:pPr>
-            <a:r>
-              <a:t>📍 Lagos, Nigeria</a:t>
-            </a:r>
-          </a:p>
-          <a:p>
-            <a:pPr>
-              <a:spcBef>
-                <a:spcPts val="600"/>
-              </a:spcBef>
-              <a:defRPr sz="1000"/>
-            </a:pPr>
-            <a:r>
-              <a:rPr b="1">
-                <a:solidFill>
-                  <a:srgbClr val="F8FAFC"/>
-                </a:solidFill>
-              </a:rPr>
-              <a:t>Challenge: </a:t>
-            </a:r>
-            <a:r>
-              <a:rPr>
-                <a:solidFill>
-                  <a:srgbClr val="94A3B8"/>
-                </a:solidFill>
-              </a:rPr>
-              <a:t>Frequent power outages &amp; expensive mobile data bundles. Cloud simulators freeze when offline.</a:t>
-            </a:r>
-          </a:p>
-          <a:p>
-            <a:pPr>
-              <a:spcBef>
-                <a:spcPts val="600"/>
-              </a:spcBef>
-              <a:defRPr sz="1000"/>
-            </a:pPr>
-            <a:r>
-              <a:rPr b="1">
-                <a:solidFill>
-                  <a:srgbClr val="F8FAFC"/>
-                </a:solidFill>
-              </a:rPr>
-              <a:t>The Hook: </a:t>
-            </a:r>
-            <a:r>
-              <a:rPr>
-                <a:solidFill>
-                  <a:srgbClr val="94A3B8"/>
-                </a:solidFill>
-              </a:rPr>
-              <a:t>Studies 100% offline via PWA caching; receives background notifications when it's time to review.</a:t>
-            </a:r>
-          </a:p>
-          <a:p>
-            <a:pPr>
-              <a:spcBef>
-                <a:spcPts val="600"/>
-              </a:spcBef>
-              <a:defRPr sz="1000"/>
-            </a:pPr>
-            <a:r>
-              <a:rPr b="1">
-                <a:solidFill>
-                  <a:srgbClr val="F8FAFC"/>
-                </a:solidFill>
-              </a:rPr>
-              <a:t>Outcome: </a:t>
-            </a:r>
-            <a:r>
-              <a:rPr>
-                <a:solidFill>
-                  <a:srgbClr val="94A3B8"/>
-                </a:solidFill>
-              </a:rPr>
-              <a:t>Saved $15/month on mobile data bundles.</a:t>
-            </a:r>
-          </a:p>
-        </p:txBody>
-      </p:sp>
-      <p:sp>
-        <p:nvSpPr>
-          <p:cNvPr id="10" name="Rounded Rectangle 9"/>
-          <p:cNvSpPr/>
-          <p:nvPr/>
-        </p:nvSpPr>
-        <p:spPr>
-          <a:xfrm>
-            <a:off x="8046720" y="1920240"/>
-            <a:ext cx="3383280" cy="3200400"/>
-          </a:xfrm>
-          <a:prstGeom prst="roundRect">
-            <a:avLst/>
-          </a:prstGeom>
-          <a:solidFill>
-            <a:srgbClr val="151E34"/>
-          </a:solidFill>
-          <a:ln w="19050">
-            <a:solidFill>
-              <a:srgbClr val="2D4166"/>
-            </a:solidFill>
-          </a:ln>
-        </p:spPr>
-        <p:style>
-          <a:lnRef idx="1">
-            <a:schemeClr val="accent1"/>
-          </a:lnRef>
-          <a:fillRef idx="3">
-            <a:schemeClr val="accent1"/>
-          </a:fillRef>
-          <a:effectRef idx="2">
-            <a:schemeClr val="accent1"/>
-          </a:effectRef>
-          <a:fontRef idx="minor">
-            <a:schemeClr val="lt1"/>
-          </a:fontRef>
-        </p:style>
-        <p:txBody>
-          <a:bodyPr rtlCol="0" anchor="ctr"/>
-          <a:lstStyle/>
-          <a:p>
-            <a:pPr algn="ctr"/>
-          </a:p>
-        </p:txBody>
-      </p:sp>
-      <p:sp>
-        <p:nvSpPr>
-          <p:cNvPr id="11" name="TextBox 10"/>
-          <p:cNvSpPr txBox="1"/>
-          <p:nvPr/>
-        </p:nvSpPr>
-        <p:spPr>
-          <a:xfrm>
-            <a:off x="8183880" y="2057400"/>
-            <a:ext cx="3108960" cy="2926080"/>
-          </a:xfrm>
-          <a:prstGeom prst="rect">
-            <a:avLst/>
-          </a:prstGeom>
-          <a:noFill/>
-        </p:spPr>
-        <p:txBody>
-          <a:bodyPr wrap="square">
-            <a:spAutoFit/>
-          </a:bodyPr>
-          <a:lstStyle/>
-          <a:p>
-            <a:pPr>
-              <a:defRPr sz="1300" b="1">
-                <a:solidFill>
-                  <a:srgbClr val="10B981"/>
-                </a:solidFill>
-              </a:defRPr>
-            </a:pPr>
-            <a:r>
-              <a:t>Jean-Luc (Career Transitioner)</a:t>
-            </a:r>
-          </a:p>
-          <a:p>
-            <a:pPr>
-              <a:defRPr sz="1000">
-                <a:solidFill>
-                  <a:srgbClr val="94A3B8"/>
-                </a:solidFill>
-              </a:defRPr>
-            </a:pPr>
-            <a:r>
-              <a:t>📍 Kigali, Rwanda</a:t>
-            </a:r>
-          </a:p>
-          <a:p>
-            <a:pPr>
-              <a:spcBef>
-                <a:spcPts val="600"/>
-              </a:spcBef>
-              <a:defRPr sz="1000"/>
-            </a:pPr>
-            <a:r>
-              <a:rPr b="1">
-                <a:solidFill>
-                  <a:srgbClr val="F8FAFC"/>
-                </a:solidFill>
-              </a:rPr>
-              <a:t>Challenge: </a:t>
-            </a:r>
-            <a:r>
-              <a:rPr>
-                <a:solidFill>
-                  <a:srgbClr val="94A3B8"/>
-                </a:solidFill>
-              </a:rPr>
-              <a:t>Non-technical background; English is a second language; overwhelmed by dense documentation.</a:t>
-            </a:r>
-          </a:p>
-          <a:p>
-            <a:pPr>
-              <a:spcBef>
-                <a:spcPts val="600"/>
-              </a:spcBef>
-              <a:defRPr sz="1000"/>
-            </a:pPr>
-            <a:r>
-              <a:rPr b="1">
-                <a:solidFill>
-                  <a:srgbClr val="F8FAFC"/>
-                </a:solidFill>
-              </a:rPr>
-              <a:t>The Hook: </a:t>
-            </a:r>
-            <a:r>
-              <a:rPr>
-                <a:solidFill>
-                  <a:srgbClr val="94A3B8"/>
-                </a:solidFill>
-              </a:rPr>
-              <a:t>Learned IaaS vs PaaS through communal farming granaries in French &amp; Kiswahili with audio read-aloud.</a:t>
-            </a:r>
-          </a:p>
-          <a:p>
-            <a:pPr>
-              <a:spcBef>
-                <a:spcPts val="600"/>
-              </a:spcBef>
-              <a:defRPr sz="1000"/>
-            </a:pPr>
-            <a:r>
-              <a:rPr b="1">
-                <a:solidFill>
-                  <a:srgbClr val="F8FAFC"/>
-                </a:solidFill>
-              </a:rPr>
-              <a:t>Outcome: </a:t>
-            </a:r>
-            <a:r>
-              <a:rPr>
-                <a:solidFill>
-                  <a:srgbClr val="94A3B8"/>
-                </a:solidFill>
-              </a:rPr>
-              <a:t>Eliminated exam anxiety; booked test date.</a:t>
-            </a:r>
-          </a:p>
-        </p:txBody>
-      </p:sp>
-      <p:sp>
-        <p:nvSpPr>
-          <p:cNvPr id="12" name="Rounded Rectangle 11"/>
-          <p:cNvSpPr/>
-          <p:nvPr/>
-        </p:nvSpPr>
-        <p:spPr>
-          <a:xfrm>
-            <a:off x="731520" y="5303520"/>
-            <a:ext cx="10698480" cy="1188720"/>
-          </a:xfrm>
-          <a:prstGeom prst="roundRect">
-            <a:avLst/>
-          </a:prstGeom>
-          <a:solidFill>
-            <a:srgbClr val="0F172A"/>
-          </a:solidFill>
-          <a:ln w="19050">
-            <a:solidFill>
-              <a:srgbClr val="F59E0B"/>
-            </a:solidFill>
-          </a:ln>
-        </p:spPr>
-        <p:style>
-          <a:lnRef idx="1">
-            <a:schemeClr val="accent1"/>
-          </a:lnRef>
-          <a:fillRef idx="3">
-            <a:schemeClr val="accent1"/>
-          </a:fillRef>
-          <a:effectRef idx="2">
-            <a:schemeClr val="accent1"/>
-          </a:effectRef>
-          <a:fontRef idx="minor">
-            <a:schemeClr val="lt1"/>
-          </a:fontRef>
-        </p:style>
-        <p:txBody>
-          <a:bodyPr rtlCol="0" anchor="ctr"/>
-          <a:lstStyle/>
-          <a:p>
-            <a:pPr algn="ctr"/>
-          </a:p>
-        </p:txBody>
-      </p:sp>
-      <p:sp>
-        <p:nvSpPr>
-          <p:cNvPr id="13" name="TextBox 12"/>
-          <p:cNvSpPr txBox="1"/>
-          <p:nvPr/>
-        </p:nvSpPr>
-        <p:spPr>
-          <a:xfrm>
-            <a:off x="914400" y="5394960"/>
-            <a:ext cx="10332720" cy="1005840"/>
-          </a:xfrm>
-          <a:prstGeom prst="rect">
-            <a:avLst/>
-          </a:prstGeom>
-          <a:noFill/>
-        </p:spPr>
-        <p:txBody>
-          <a:bodyPr wrap="square">
-            <a:spAutoFit/>
-          </a:bodyPr>
-          <a:lstStyle/>
-          <a:p>
-            <a:pPr>
-              <a:defRPr sz="1200" b="1">
-                <a:solidFill>
-                  <a:srgbClr val="F59E0B"/>
-                </a:solidFill>
-              </a:defRPr>
-            </a:pPr>
-            <a:r>
-              <a:t>🌍 PEDAGOGICAL LOCALIZATION: 4 LANGUAGES &amp; EVERYDAY CULTURAL ANCHORS</a:t>
-            </a:r>
-          </a:p>
-          <a:p>
-            <a:pPr>
-              <a:spcBef>
-                <a:spcPts val="400"/>
-              </a:spcBef>
-              <a:defRPr sz="1050">
-                <a:solidFill>
-                  <a:srgbClr val="F8FAFC"/>
-                </a:solidFill>
-              </a:defRPr>
-            </a:pPr>
-            <a:r>
-              <a:t>• Multilingual Explanations: Full vernacular support in English, Kiswahili/Sheng, Nigerian Pidgin, and French.</a:t>
-            </a:r>
-            <a:br/>
-            <a:r>
-              <a:t>• Culturally Grounded Analogies: Azure Regions = African Trading Corridors | Availability Zones = Independent Power Sub-stations</a:t>
-            </a:r>
-            <a:br/>
-            <a:r>
-              <a:t>• Granary vs Renting: Cloud Capital vs Operational Expenditure explained using community harvest silos.</a:t>
-            </a:r>
-          </a:p>
-        </p:txBody>
-      </p:sp>
-    </p:spTree>
-  </p:cSld>
-  <p:clrMapOvr>
-    <a:masterClrMapping/>
-  </p:clrMapOvr>
-</p:sld>
-</file>
-
-<file path=ppt/slides/slide4.xml><?xml version="1.0" encoding="utf-8"?>
-<p:sld xmlns:a="http://schemas.openxmlformats.org/drawingml/2006/main" xmlns:p="http://schemas.openxmlformats.org/presentationml/2006/main" xmlns:r="http://schemas.openxmlformats.org/officeDocument/2006/relationships">
-  <p:cSld>
-    <p:spTree>
-      <p:nvGrpSpPr>
-        <p:cNvPr id="1" name=""/>
-        <p:cNvGrpSpPr/>
-        <p:nvPr/>
-      </p:nvGrpSpPr>
-      <p:grpSpPr/>
-      <p:sp>
-        <p:nvSpPr>
-          <p:cNvPr id="2" name="Rectangle 1"/>
-          <p:cNvSpPr/>
-          <p:nvPr/>
-        </p:nvSpPr>
-        <p:spPr>
-          <a:xfrm>
-            <a:off x="0" y="0"/>
-            <a:ext cx="12191695" cy="6858000"/>
-          </a:xfrm>
-          <a:prstGeom prst="rect">
-            <a:avLst/>
-          </a:prstGeom>
-          <a:solidFill>
-            <a:srgbClr val="0A0F1D"/>
-          </a:solidFill>
-          <a:ln>
-            <a:noFill/>
-          </a:ln>
-        </p:spPr>
-        <p:style>
-          <a:lnRef idx="1">
-            <a:schemeClr val="accent1"/>
-          </a:lnRef>
-          <a:fillRef idx="3">
-            <a:schemeClr val="accent1"/>
-          </a:fillRef>
-          <a:effectRef idx="2">
-            <a:schemeClr val="accent1"/>
-          </a:effectRef>
-          <a:fontRef idx="minor">
-            <a:schemeClr val="lt1"/>
-          </a:fontRef>
-        </p:style>
-        <p:txBody>
-          <a:bodyPr rtlCol="0" anchor="ctr"/>
-          <a:lstStyle/>
-          <a:p>
-            <a:pPr algn="ctr"/>
-          </a:p>
-        </p:txBody>
-      </p:sp>
-      <p:sp>
-        <p:nvSpPr>
-          <p:cNvPr id="3" name="Rounded Rectangle 2"/>
-          <p:cNvSpPr/>
-          <p:nvPr/>
-        </p:nvSpPr>
-        <p:spPr>
-          <a:xfrm>
-            <a:off x="731520" y="365760"/>
-            <a:ext cx="4206240" cy="320040"/>
-          </a:xfrm>
-          <a:prstGeom prst="roundRect">
-            <a:avLst/>
-          </a:prstGeom>
-          <a:solidFill>
-            <a:srgbClr val="1E293B"/>
-          </a:solidFill>
-          <a:ln>
-            <a:noFill/>
-          </a:ln>
-        </p:spPr>
-        <p:style>
-          <a:lnRef idx="1">
-            <a:schemeClr val="accent1"/>
-          </a:lnRef>
-          <a:fillRef idx="3">
-            <a:schemeClr val="accent1"/>
-          </a:fillRef>
-          <a:effectRef idx="2">
-            <a:schemeClr val="accent1"/>
-          </a:effectRef>
-          <a:fontRef idx="minor">
-            <a:schemeClr val="lt1"/>
-          </a:fontRef>
-        </p:style>
-        <p:txBody>
-          <a:bodyPr rtlCol="0" anchor="ctr"/>
-          <a:lstStyle/>
-          <a:p>
-            <a:pPr algn="ctr">
-              <a:defRPr sz="1000" b="1">
-                <a:solidFill>
-                  <a:srgbClr val="38BDF8"/>
-                </a:solidFill>
-                <a:latin typeface="Segoe UI"/>
-              </a:defRPr>
-            </a:pPr>
-            <a:r>
-              <a:t>UNIVERSAL INCLUSION &amp; HORIZONTAL SCALE  |  RUBRIC: 20 PTS</a:t>
-            </a:r>
-          </a:p>
-        </p:txBody>
-      </p:sp>
-      <p:sp>
-        <p:nvSpPr>
-          <p:cNvPr id="4" name="TextBox 3"/>
-          <p:cNvSpPr txBox="1"/>
-          <p:nvPr/>
-        </p:nvSpPr>
-        <p:spPr>
-          <a:xfrm>
-            <a:off x="731520" y="749808"/>
-            <a:ext cx="10698480" cy="594360"/>
-          </a:xfrm>
-          <a:prstGeom prst="rect">
-            <a:avLst/>
-          </a:prstGeom>
-          <a:noFill/>
-        </p:spPr>
-        <p:txBody>
-          <a:bodyPr wrap="square">
-            <a:spAutoFit/>
-          </a:bodyPr>
-          <a:lstStyle/>
-          <a:p>
-            <a:pPr>
-              <a:defRPr sz="2400" b="1">
-                <a:solidFill>
-                  <a:srgbClr val="F8FAFC"/>
-                </a:solidFill>
-                <a:latin typeface="Segoe UI"/>
-              </a:defRPr>
-            </a:pPr>
-            <a:r>
-              <a:t>No Learner Left Behind: Target WCAG 2.1 AAA &amp; Infinite Scale</a:t>
-            </a:r>
-          </a:p>
-        </p:txBody>
-      </p:sp>
-      <p:sp>
-        <p:nvSpPr>
-          <p:cNvPr id="5" name="TextBox 4"/>
-          <p:cNvSpPr txBox="1"/>
-          <p:nvPr/>
-        </p:nvSpPr>
-        <p:spPr>
-          <a:xfrm>
-            <a:off x="731520" y="1325880"/>
-            <a:ext cx="10698480" cy="411480"/>
-          </a:xfrm>
-          <a:prstGeom prst="rect">
-            <a:avLst/>
-          </a:prstGeom>
-          <a:noFill/>
-        </p:spPr>
-        <p:txBody>
-          <a:bodyPr wrap="square">
-            <a:spAutoFit/>
-          </a:bodyPr>
-          <a:lstStyle/>
-          <a:p>
-            <a:pPr>
-              <a:defRPr sz="1300" i="1">
-                <a:solidFill>
-                  <a:srgbClr val="F59E0B"/>
-                </a:solidFill>
-                <a:latin typeface="Segoe UI"/>
-              </a:defRPr>
-            </a:pPr>
-            <a:r>
-              <a:t>Accessibility-First Engineering Meets Cost-Free Serverless Scalability</a:t>
-            </a:r>
-          </a:p>
-        </p:txBody>
-      </p:sp>
-      <p:sp>
-        <p:nvSpPr>
-          <p:cNvPr id="6" name="Rounded Rectangle 5"/>
-          <p:cNvSpPr/>
-          <p:nvPr/>
-        </p:nvSpPr>
-        <p:spPr>
-          <a:xfrm>
-            <a:off x="731520" y="1920240"/>
-            <a:ext cx="5120640" cy="4297680"/>
-          </a:xfrm>
-          <a:prstGeom prst="roundRect">
-            <a:avLst/>
-          </a:prstGeom>
-          <a:solidFill>
-            <a:srgbClr val="151E34"/>
-          </a:solidFill>
-          <a:ln w="19050">
-            <a:solidFill>
-              <a:srgbClr val="2D4166"/>
-            </a:solidFill>
-          </a:ln>
-        </p:spPr>
-        <p:style>
-          <a:lnRef idx="1">
-            <a:schemeClr val="accent1"/>
-          </a:lnRef>
-          <a:fillRef idx="3">
-            <a:schemeClr val="accent1"/>
-          </a:fillRef>
-          <a:effectRef idx="2">
-            <a:schemeClr val="accent1"/>
-          </a:effectRef>
-          <a:fontRef idx="minor">
-            <a:schemeClr val="lt1"/>
-          </a:fontRef>
-        </p:style>
-        <p:txBody>
-          <a:bodyPr rtlCol="0" anchor="ctr"/>
-          <a:lstStyle/>
-          <a:p>
-            <a:pPr algn="ctr"/>
-          </a:p>
-        </p:txBody>
-      </p:sp>
-      <p:sp>
-        <p:nvSpPr>
-          <p:cNvPr id="7" name="TextBox 6"/>
-          <p:cNvSpPr txBox="1"/>
-          <p:nvPr/>
-        </p:nvSpPr>
-        <p:spPr>
-          <a:xfrm>
-            <a:off x="914400" y="2103120"/>
-            <a:ext cx="4754880" cy="3931920"/>
-          </a:xfrm>
-          <a:prstGeom prst="rect">
-            <a:avLst/>
-          </a:prstGeom>
-          <a:noFill/>
-        </p:spPr>
-        <p:txBody>
-          <a:bodyPr wrap="square">
-            <a:spAutoFit/>
-          </a:bodyPr>
-          <a:lstStyle/>
-          <a:p>
-            <a:pPr>
-              <a:defRPr sz="1500" b="1">
-                <a:solidFill>
-                  <a:srgbClr val="10B981"/>
-                </a:solidFill>
-              </a:defRPr>
-            </a:pPr>
-            <a:r>
-              <a:t>UNIVERSAL ACCESSIBILITY (WCAG 2.1 AAA)</a:t>
-            </a:r>
-          </a:p>
-          <a:p>
-            <a:pPr>
-              <a:spcBef>
-                <a:spcPts val="800"/>
-              </a:spcBef>
-              <a:defRPr sz="1050"/>
-            </a:pPr>
-            <a:r>
-              <a:rPr b="1">
-                <a:solidFill>
-                  <a:srgbClr val="F8FAFC"/>
-                </a:solidFill>
-              </a:rPr>
-              <a:t>♿ Web Speech Text-to-Speech: </a:t>
-            </a:r>
-            <a:r>
-              <a:rPr>
-                <a:solidFill>
-                  <a:srgbClr val="94A3B8"/>
-                </a:solidFill>
-              </a:rPr>
-              <a:t>Full offline audio read-aloud for visually impaired learners and busy commuters.</a:t>
-            </a:r>
-          </a:p>
-          <a:p>
-            <a:pPr>
-              <a:spcBef>
-                <a:spcPts val="800"/>
-              </a:spcBef>
-              <a:defRPr sz="1050"/>
-            </a:pPr>
-            <a:r>
-              <a:rPr b="1">
-                <a:solidFill>
-                  <a:srgbClr val="F8FAFC"/>
-                </a:solidFill>
-              </a:rPr>
-              <a:t>♿ Dyslexia-Optimized Typography: </a:t>
-            </a:r>
-            <a:r>
-              <a:rPr>
-                <a:solidFill>
-                  <a:srgbClr val="94A3B8"/>
-                </a:solidFill>
-              </a:rPr>
-              <a:t>High-legibility letter spacing, line height, and font-weight toggles eliminate visual crowding.</a:t>
-            </a:r>
-          </a:p>
-          <a:p>
-            <a:pPr>
-              <a:spcBef>
-                <a:spcPts val="800"/>
-              </a:spcBef>
-              <a:defRPr sz="1050"/>
-            </a:pPr>
-            <a:r>
-              <a:rPr b="1">
-                <a:solidFill>
-                  <a:srgbClr val="F8FAFC"/>
-                </a:solidFill>
-              </a:rPr>
-              <a:t>♿ High-Contrast Mode: </a:t>
-            </a:r>
-            <a:r>
-              <a:rPr>
-                <a:solidFill>
-                  <a:srgbClr val="94A3B8"/>
-                </a:solidFill>
-              </a:rPr>
-              <a:t>Calculated AAA contrast ratios (7:1+) for low-light conditions and OLED power saving.</a:t>
-            </a:r>
-          </a:p>
-          <a:p>
-            <a:pPr>
-              <a:spcBef>
-                <a:spcPts val="800"/>
-              </a:spcBef>
-              <a:defRPr sz="1050"/>
-            </a:pPr>
-            <a:r>
-              <a:rPr b="1">
-                <a:solidFill>
-                  <a:srgbClr val="F8FAFC"/>
-                </a:solidFill>
-              </a:rPr>
-              <a:t>♿ 100% Keyboard Navigability: </a:t>
-            </a:r>
-            <a:r>
-              <a:rPr>
-                <a:solidFill>
-                  <a:srgbClr val="94A3B8"/>
-                </a:solidFill>
-              </a:rPr>
-              <a:t>Single-hand physical controls (1-4 answers, Enter, N for next mission, Space for flip).</a:t>
-            </a:r>
-          </a:p>
-          <a:p>
-            <a:pPr>
-              <a:spcBef>
-                <a:spcPts val="800"/>
-              </a:spcBef>
-              <a:defRPr sz="1050"/>
-            </a:pPr>
-            <a:r>
-              <a:rPr b="1">
-                <a:solidFill>
-                  <a:srgbClr val="F8FAFC"/>
-                </a:solidFill>
-              </a:rPr>
-              <a:t>♿ Screen Reader ARIA Live: </a:t>
-            </a:r>
-            <a:r>
-              <a:rPr>
-                <a:solidFill>
-                  <a:srgbClr val="94A3B8"/>
-                </a:solidFill>
-              </a:rPr>
-              <a:t>Automated announcements for score updates and question transitions.</a:t>
+              <a:t>Prevents learners from risking $99 exam vouchers before their weighted readiness hits 75%+.</a:t>
             </a:r>
           </a:p>
         </p:txBody>
@@ -6292,7 +4189,7 @@
         </p:nvSpPr>
         <p:spPr>
           <a:xfrm>
-            <a:off x="6400800" y="2103120"/>
+            <a:off x="6400800" y="2057400"/>
             <a:ext cx="4846320" cy="3931920"/>
           </a:xfrm>
           <a:prstGeom prst="rect">
@@ -6307,14 +4204,14 @@
           <a:lstStyle/>
           <a:p>
             <a:pPr>
-              <a:defRPr sz="1500" b="1">
-                <a:solidFill>
-                  <a:srgbClr val="38BDF8"/>
+              <a:defRPr sz="1400" b="1">
+                <a:solidFill>
+                  <a:srgbClr val="F59E0B"/>
                 </a:solidFill>
               </a:defRPr>
             </a:pPr>
             <a:r>
-              <a:t>EXPONENTIAL IMPACT &amp; ECOSYSTEM SCALE</a:t>
+              <a:t>COGNITIVE LOCK &amp; DISTRACTOR ANALYSIS</a:t>
             </a:r>
           </a:p>
           <a:p>
@@ -6327,10 +4224,10 @@
             <a:r>
               <a:rPr b="1">
                 <a:solidFill>
-                  <a:srgbClr val="F59E0B"/>
-                </a:solidFill>
-              </a:rPr>
-              <a:t>🚀 $0.00 Cost per Student: </a:t>
+                  <a:srgbClr val="10B981"/>
+                </a:solidFill>
+              </a:rPr>
+              <a:t>✓ The 'Why It's Wrong' Gap: </a:t>
             </a:r>
             <a:r>
               <a:rPr>
@@ -6338,7 +4235,7 @@
                   <a:srgbClr val="94A3B8"/>
                 </a:solidFill>
               </a:rPr>
-              <a:t>100% client-side computing and static edge delivery means zero recurring server costs as user base grows to 1,000,000 learners.</a:t>
+              <a:t>Standard test dumps only show which option is correct. AfriCloud breaks down every single wrong option (distractors) to explain WHY it fails.</a:t>
             </a:r>
           </a:p>
           <a:p>
@@ -6351,10 +4248,10 @@
             <a:r>
               <a:rPr b="1">
                 <a:solidFill>
-                  <a:srgbClr val="F59E0B"/>
-                </a:solidFill>
-              </a:rPr>
-              <a:t>🚀 Pluggable Certification Engine: </a:t>
+                  <a:srgbClr val="10B981"/>
+                </a:solidFill>
+              </a:rPr>
+              <a:t>✓ Active Recall Memory Locks: </a:t>
             </a:r>
             <a:r>
               <a:rPr>
@@ -6362,7 +4259,7 @@
                   <a:srgbClr val="94A3B8"/>
                 </a:solidFill>
               </a:rPr>
-              <a:t>Modular JSON schema architecture. The cognitive engine can ingest AWS Cloud Practitioner (CLF-C02), GCP Digital Leader, or AZ-104 with zero UI rewrites.</a:t>
+              <a:t>High-yield spaced-repetition flashcards ensure long-term retention of critical parameters (SLA percentages, CapEx vs OpEx, Blob storage tiers).</a:t>
             </a:r>
           </a:p>
           <a:p>
@@ -6375,10 +4272,10 @@
             <a:r>
               <a:rPr b="1">
                 <a:solidFill>
-                  <a:srgbClr val="F59E0B"/>
-                </a:solidFill>
-              </a:rPr>
-              <a:t>🚀 Talent Pipeline for Tech Hubs: </a:t>
+                  <a:srgbClr val="10B981"/>
+                </a:solidFill>
+              </a:rPr>
+              <a:t>✓ Automated Weak Area Pitstops: </a:t>
             </a:r>
             <a:r>
               <a:rPr>
@@ -6386,7 +4283,7 @@
                   <a:srgbClr val="94A3B8"/>
                 </a:solidFill>
               </a:rPr>
-              <a:t>Helps meet Africa's booming cloud talent demand by converting raw enthusiasm into verifiable certifications.</a:t>
+              <a:t>Subtopics scoring below 70% (e.g. Azure Networking at 0%) trigger automated remediation pitstops directly on the roadmap.</a:t>
             </a:r>
           </a:p>
           <a:p>
@@ -6399,10 +4296,10 @@
             <a:r>
               <a:rPr b="1">
                 <a:solidFill>
-                  <a:srgbClr val="F59E0B"/>
-                </a:solidFill>
-              </a:rPr>
-              <a:t>🚀 Open Educational Resource: </a:t>
+                  <a:srgbClr val="10B981"/>
+                </a:solidFill>
+              </a:rPr>
+              <a:t>✓ Real Scenario Questions: </a:t>
             </a:r>
             <a:r>
               <a:rPr>
@@ -6410,7 +4307,7 @@
                   <a:srgbClr val="94A3B8"/>
                 </a:solidFill>
               </a:rPr>
-              <a:t>Published open source under MIT License for university coding clubs and local developer communities across the continent.</a:t>
+              <a:t>Scenario-based practice questions replace mindless trivia memorization with enterprise problem-solving.</a:t>
             </a:r>
           </a:p>
         </p:txBody>
@@ -6423,7 +4320,7 @@
 </p:sld>
 </file>
 
-<file path=ppt/slides/slide5.xml><?xml version="1.0" encoding="utf-8"?>
+<file path=ppt/slides/slide2.xml><?xml version="1.0" encoding="utf-8"?>
 <p:sld xmlns:a="http://schemas.openxmlformats.org/drawingml/2006/main" xmlns:p="http://schemas.openxmlformats.org/presentationml/2006/main" xmlns:r="http://schemas.openxmlformats.org/officeDocument/2006/relationships">
   <p:cSld>
     <p:spTree>
@@ -6485,7 +4382,7 @@
         <p:spPr>
           <a:xfrm>
             <a:off x="731520" y="365760"/>
-            <a:ext cx="4206240" cy="320040"/>
+            <a:ext cx="5303520" cy="320040"/>
           </a:xfrm>
           <a:prstGeom prst="roundRect">
             <a:avLst/>
@@ -6524,7 +4421,7 @@
               </a:defRPr>
             </a:pPr>
             <a:r>
-              <a:t>OPEN SOURCE, VERIFIED &amp; LIVE  |  RUBRIC: 20 PTS</a:t>
+              <a:t>RUBRIC CRITERION 2: 🔍 PROMPT ENGINEERING  |  WEIGHT: 20%</a:t>
             </a:r>
           </a:p>
         </p:txBody>
@@ -6552,7 +4449,7 @@
           <a:lstStyle/>
           <a:p>
             <a:pPr>
-              <a:defRPr sz="2400" b="1">
+              <a:defRPr sz="2300" b="1">
                 <a:solidFill>
                   <a:srgbClr val="F8FAFC"/>
                 </a:solidFill>
@@ -6560,7 +4457,7 @@
               </a:defRPr>
             </a:pPr>
             <a:r>
-              <a:t>Vibe Coding in Action: Fast, Open, and Ready to Try</a:t>
+              <a:t>Intelligent AI Architecture: 'Rafiki' Cloud Mentor</a:t>
             </a:r>
           </a:p>
         </p:txBody>
@@ -6588,7 +4485,7 @@
           <a:lstStyle/>
           <a:p>
             <a:pPr>
-              <a:defRPr sz="1300" i="1">
+              <a:defRPr sz="1250" i="1">
                 <a:solidFill>
                   <a:srgbClr val="F59E0B"/>
                 </a:solidFill>
@@ -6596,7 +4493,1621 @@
               </a:defRPr>
             </a:pPr>
             <a:r>
-              <a:t>Built in 48 Hours | Deployed Globally | 100% Open Source Community Study Tool</a:t>
+              <a:t>Multi-Tier Guardrails, Grounded African Metaphors, and Structured Dynamic Ingestion</a:t>
+            </a:r>
+          </a:p>
+        </p:txBody>
+      </p:sp>
+      <p:sp>
+        <p:nvSpPr>
+          <p:cNvPr id="6" name="Rounded Rectangle 5"/>
+          <p:cNvSpPr/>
+          <p:nvPr/>
+        </p:nvSpPr>
+        <p:spPr>
+          <a:xfrm>
+            <a:off x="731520" y="1920240"/>
+            <a:ext cx="5212080" cy="4297680"/>
+          </a:xfrm>
+          <a:prstGeom prst="roundRect">
+            <a:avLst/>
+          </a:prstGeom>
+          <a:solidFill>
+            <a:srgbClr val="151E34"/>
+          </a:solidFill>
+          <a:ln w="19050">
+            <a:solidFill>
+              <a:srgbClr val="2D4166"/>
+            </a:solidFill>
+          </a:ln>
+        </p:spPr>
+        <p:style>
+          <a:lnRef idx="1">
+            <a:schemeClr val="accent1"/>
+          </a:lnRef>
+          <a:fillRef idx="3">
+            <a:schemeClr val="accent1"/>
+          </a:fillRef>
+          <a:effectRef idx="2">
+            <a:schemeClr val="accent1"/>
+          </a:effectRef>
+          <a:fontRef idx="minor">
+            <a:schemeClr val="lt1"/>
+          </a:fontRef>
+        </p:style>
+        <p:txBody>
+          <a:bodyPr rtlCol="0" anchor="ctr"/>
+          <a:lstStyle/>
+          <a:p>
+            <a:pPr algn="ctr"/>
+          </a:p>
+        </p:txBody>
+      </p:sp>
+      <p:sp>
+        <p:nvSpPr>
+          <p:cNvPr id="7" name="TextBox 6"/>
+          <p:cNvSpPr txBox="1"/>
+          <p:nvPr/>
+        </p:nvSpPr>
+        <p:spPr>
+          <a:xfrm>
+            <a:off x="914400" y="2057400"/>
+            <a:ext cx="4846320" cy="3931920"/>
+          </a:xfrm>
+          <a:prstGeom prst="rect">
+            <a:avLst/>
+          </a:prstGeom>
+          <a:noFill/>
+        </p:spPr>
+        <p:txBody>
+          <a:bodyPr wrap="square">
+            <a:spAutoFit/>
+          </a:bodyPr>
+          <a:lstStyle/>
+          <a:p>
+            <a:pPr>
+              <a:defRPr sz="1400" b="1">
+                <a:solidFill>
+                  <a:srgbClr val="38BDF8"/>
+                </a:solidFill>
+              </a:defRPr>
+            </a:pPr>
+            <a:r>
+              <a:t>SYSTEM PROMPT GUARDRAILS &amp; STRUCTURE</a:t>
+            </a:r>
+          </a:p>
+          <a:p>
+            <a:pPr>
+              <a:spcBef>
+                <a:spcPts val="800"/>
+              </a:spcBef>
+              <a:defRPr sz="1050"/>
+            </a:pPr>
+            <a:r>
+              <a:rPr b="1">
+                <a:solidFill>
+                  <a:srgbClr val="F8FAFC"/>
+                </a:solidFill>
+              </a:rPr>
+              <a:t>🤖 Curriculum Boundary Enforcement: </a:t>
+            </a:r>
+            <a:r>
+              <a:rPr>
+                <a:solidFill>
+                  <a:srgbClr val="94A3B8"/>
+                </a:solidFill>
+              </a:rPr>
+              <a:t>System instruction strictly locks Gemini 1.5 Flash within the official AZ-900 syllabus, preventing hallucinated enterprise complexities.</a:t>
+            </a:r>
+          </a:p>
+          <a:p>
+            <a:pPr>
+              <a:spcBef>
+                <a:spcPts val="800"/>
+              </a:spcBef>
+              <a:defRPr sz="1050"/>
+            </a:pPr>
+            <a:r>
+              <a:rPr b="1">
+                <a:solidFill>
+                  <a:srgbClr val="F8FAFC"/>
+                </a:solidFill>
+              </a:rPr>
+              <a:t>🤖 Dynamic Context Injection: </a:t>
+            </a:r>
+            <a:r>
+              <a:rPr>
+                <a:solidFill>
+                  <a:srgbClr val="94A3B8"/>
+                </a:solidFill>
+              </a:rPr>
+              <a:t>Prompts dynamically ingest: [1] Learner's VARK Style, [2] Detected Topic Weakness, [3] Cultural Dialect Preference (English, Sheng, Pidgin, French).</a:t>
+            </a:r>
+          </a:p>
+          <a:p>
+            <a:pPr>
+              <a:spcBef>
+                <a:spcPts val="800"/>
+              </a:spcBef>
+              <a:defRPr sz="1050"/>
+            </a:pPr>
+            <a:r>
+              <a:rPr b="1">
+                <a:solidFill>
+                  <a:srgbClr val="F8FAFC"/>
+                </a:solidFill>
+              </a:rPr>
+              <a:t>🤖 Structured Few-Shot Templates: </a:t>
+            </a:r>
+            <a:r>
+              <a:rPr>
+                <a:solidFill>
+                  <a:srgbClr val="94A3B8"/>
+                </a:solidFill>
+              </a:rPr>
+              <a:t>Enforces strict JSON/Markdown schema output for bulleted architectural tradeoffs and CLI sandbox steps.</a:t>
+            </a:r>
+          </a:p>
+          <a:p>
+            <a:pPr>
+              <a:spcBef>
+                <a:spcPts val="800"/>
+              </a:spcBef>
+              <a:defRPr sz="1050"/>
+            </a:pPr>
+            <a:r>
+              <a:rPr b="1">
+                <a:solidFill>
+                  <a:srgbClr val="F8FAFC"/>
+                </a:solidFill>
+              </a:rPr>
+              <a:t>🤖 Deterministic Fallback Trees: </a:t>
+            </a:r>
+            <a:r>
+              <a:rPr>
+                <a:solidFill>
+                  <a:srgbClr val="94A3B8"/>
+                </a:solidFill>
+              </a:rPr>
+              <a:t>Pre-engineered fallback response trees mirror exact prompt schemas when the learner has no internet or API key.</a:t>
+            </a:r>
+          </a:p>
+        </p:txBody>
+      </p:sp>
+      <p:sp>
+        <p:nvSpPr>
+          <p:cNvPr id="8" name="Rounded Rectangle 7"/>
+          <p:cNvSpPr/>
+          <p:nvPr/>
+        </p:nvSpPr>
+        <p:spPr>
+          <a:xfrm>
+            <a:off x="6217920" y="1920240"/>
+            <a:ext cx="5212080" cy="4297680"/>
+          </a:xfrm>
+          <a:prstGeom prst="roundRect">
+            <a:avLst/>
+          </a:prstGeom>
+          <a:solidFill>
+            <a:srgbClr val="151E34"/>
+          </a:solidFill>
+          <a:ln w="19050">
+            <a:solidFill>
+              <a:srgbClr val="2D4166"/>
+            </a:solidFill>
+          </a:ln>
+        </p:spPr>
+        <p:style>
+          <a:lnRef idx="1">
+            <a:schemeClr val="accent1"/>
+          </a:lnRef>
+          <a:fillRef idx="3">
+            <a:schemeClr val="accent1"/>
+          </a:fillRef>
+          <a:effectRef idx="2">
+            <a:schemeClr val="accent1"/>
+          </a:effectRef>
+          <a:fontRef idx="minor">
+            <a:schemeClr val="lt1"/>
+          </a:fontRef>
+        </p:style>
+        <p:txBody>
+          <a:bodyPr rtlCol="0" anchor="ctr"/>
+          <a:lstStyle/>
+          <a:p>
+            <a:pPr algn="ctr"/>
+          </a:p>
+        </p:txBody>
+      </p:sp>
+      <p:sp>
+        <p:nvSpPr>
+          <p:cNvPr id="9" name="TextBox 8"/>
+          <p:cNvSpPr txBox="1"/>
+          <p:nvPr/>
+        </p:nvSpPr>
+        <p:spPr>
+          <a:xfrm>
+            <a:off x="6400800" y="2057400"/>
+            <a:ext cx="4846320" cy="3931920"/>
+          </a:xfrm>
+          <a:prstGeom prst="rect">
+            <a:avLst/>
+          </a:prstGeom>
+          <a:noFill/>
+        </p:spPr>
+        <p:txBody>
+          <a:bodyPr wrap="square">
+            <a:spAutoFit/>
+          </a:bodyPr>
+          <a:lstStyle/>
+          <a:p>
+            <a:pPr>
+              <a:defRPr sz="1400" b="1">
+                <a:solidFill>
+                  <a:srgbClr val="F59E0B"/>
+                </a:solidFill>
+              </a:defRPr>
+            </a:pPr>
+            <a:r>
+              <a:t>PURPOSEFUL AFRICAN PEDAGOGICAL PROMPTING</a:t>
+            </a:r>
+          </a:p>
+          <a:p>
+            <a:pPr>
+              <a:spcBef>
+                <a:spcPts val="800"/>
+              </a:spcBef>
+              <a:defRPr sz="1050"/>
+            </a:pPr>
+            <a:r>
+              <a:rPr b="1">
+                <a:solidFill>
+                  <a:srgbClr val="10B981"/>
+                </a:solidFill>
+              </a:rPr>
+              <a:t>🌍 High Availability &amp; Fault Tolerance: </a:t>
+            </a:r>
+            <a:r>
+              <a:rPr>
+                <a:solidFill>
+                  <a:srgbClr val="94A3B8"/>
+                </a:solidFill>
+              </a:rPr>
+              <a:t>Prompted to explain regional redundancy via M-Pesa agent float rebalancing across adjacent Kenyan towns.</a:t>
+            </a:r>
+          </a:p>
+          <a:p>
+            <a:pPr>
+              <a:spcBef>
+                <a:spcPts val="800"/>
+              </a:spcBef>
+              <a:defRPr sz="1050"/>
+            </a:pPr>
+            <a:r>
+              <a:rPr b="1">
+                <a:solidFill>
+                  <a:srgbClr val="10B981"/>
+                </a:solidFill>
+              </a:rPr>
+              <a:t>🌍 IaaS vs PaaS vs SaaS: </a:t>
+            </a:r>
+            <a:r>
+              <a:rPr>
+                <a:solidFill>
+                  <a:srgbClr val="94A3B8"/>
+                </a:solidFill>
+              </a:rPr>
+              <a:t>Instructed to compare cloud models to building a personal farm granary (IaaS) vs renting communal harvest space (PaaS).</a:t>
+            </a:r>
+          </a:p>
+          <a:p>
+            <a:pPr>
+              <a:spcBef>
+                <a:spcPts val="800"/>
+              </a:spcBef>
+              <a:defRPr sz="1050"/>
+            </a:pPr>
+            <a:r>
+              <a:rPr b="1">
+                <a:solidFill>
+                  <a:srgbClr val="10B981"/>
+                </a:solidFill>
+              </a:rPr>
+              <a:t>🌍 Azure VPN vs ExpressRoute: </a:t>
+            </a:r>
+            <a:r>
+              <a:rPr>
+                <a:solidFill>
+                  <a:srgbClr val="94A3B8"/>
+                </a:solidFill>
+              </a:rPr>
+              <a:t>Contrasts a bullion van on a busy public highway (VPN) vs a private dedicated high-speed railway track (ExpressRoute).</a:t>
+            </a:r>
+          </a:p>
+          <a:p>
+            <a:pPr>
+              <a:spcBef>
+                <a:spcPts val="800"/>
+              </a:spcBef>
+              <a:defRPr sz="1050"/>
+            </a:pPr>
+            <a:r>
+              <a:rPr b="1">
+                <a:solidFill>
+                  <a:srgbClr val="10B981"/>
+                </a:solidFill>
+              </a:rPr>
+              <a:t>🌍 Multilingual Vernacular: </a:t>
+            </a:r>
+            <a:r>
+              <a:rPr>
+                <a:solidFill>
+                  <a:srgbClr val="94A3B8"/>
+                </a:solidFill>
+              </a:rPr>
+              <a:t>Natively generates analogies in Kiswahili/Sheng ('reli ya SGR'), Nigerian Pidgin ('private helicopter track'), and French.</a:t>
+            </a:r>
+          </a:p>
+        </p:txBody>
+      </p:sp>
+    </p:spTree>
+  </p:cSld>
+  <p:clrMapOvr>
+    <a:masterClrMapping/>
+  </p:clrMapOvr>
+</p:sld>
+</file>
+
+<file path=ppt/slides/slide3.xml><?xml version="1.0" encoding="utf-8"?>
+<p:sld xmlns:a="http://schemas.openxmlformats.org/drawingml/2006/main" xmlns:p="http://schemas.openxmlformats.org/presentationml/2006/main" xmlns:r="http://schemas.openxmlformats.org/officeDocument/2006/relationships">
+  <p:cSld>
+    <p:spTree>
+      <p:nvGrpSpPr>
+        <p:cNvPr id="1" name=""/>
+        <p:cNvGrpSpPr/>
+        <p:nvPr/>
+      </p:nvGrpSpPr>
+      <p:grpSpPr/>
+      <p:sp>
+        <p:nvSpPr>
+          <p:cNvPr id="2" name="Rectangle 1"/>
+          <p:cNvSpPr/>
+          <p:nvPr/>
+        </p:nvSpPr>
+        <p:spPr>
+          <a:xfrm>
+            <a:off x="0" y="0"/>
+            <a:ext cx="12191695" cy="6858000"/>
+          </a:xfrm>
+          <a:prstGeom prst="rect">
+            <a:avLst/>
+          </a:prstGeom>
+          <a:solidFill>
+            <a:srgbClr val="0A0F1D"/>
+          </a:solidFill>
+          <a:ln>
+            <a:noFill/>
+          </a:ln>
+        </p:spPr>
+        <p:style>
+          <a:lnRef idx="1">
+            <a:schemeClr val="accent1"/>
+          </a:lnRef>
+          <a:fillRef idx="3">
+            <a:schemeClr val="accent1"/>
+          </a:fillRef>
+          <a:effectRef idx="2">
+            <a:schemeClr val="accent1"/>
+          </a:effectRef>
+          <a:fontRef idx="minor">
+            <a:schemeClr val="lt1"/>
+          </a:fontRef>
+        </p:style>
+        <p:txBody>
+          <a:bodyPr rtlCol="0" anchor="ctr"/>
+          <a:lstStyle/>
+          <a:p>
+            <a:pPr algn="ctr"/>
+          </a:p>
+        </p:txBody>
+      </p:sp>
+      <p:sp>
+        <p:nvSpPr>
+          <p:cNvPr id="3" name="Rounded Rectangle 2"/>
+          <p:cNvSpPr/>
+          <p:nvPr/>
+        </p:nvSpPr>
+        <p:spPr>
+          <a:xfrm>
+            <a:off x="731520" y="365760"/>
+            <a:ext cx="5303520" cy="320040"/>
+          </a:xfrm>
+          <a:prstGeom prst="roundRect">
+            <a:avLst/>
+          </a:prstGeom>
+          <a:solidFill>
+            <a:srgbClr val="1E293B"/>
+          </a:solidFill>
+          <a:ln>
+            <a:noFill/>
+          </a:ln>
+        </p:spPr>
+        <p:style>
+          <a:lnRef idx="1">
+            <a:schemeClr val="accent1"/>
+          </a:lnRef>
+          <a:fillRef idx="3">
+            <a:schemeClr val="accent1"/>
+          </a:fillRef>
+          <a:effectRef idx="2">
+            <a:schemeClr val="accent1"/>
+          </a:effectRef>
+          <a:fontRef idx="minor">
+            <a:schemeClr val="lt1"/>
+          </a:fontRef>
+        </p:style>
+        <p:txBody>
+          <a:bodyPr rtlCol="0" anchor="ctr"/>
+          <a:lstStyle/>
+          <a:p>
+            <a:pPr algn="ctr">
+              <a:defRPr sz="1000" b="1">
+                <a:solidFill>
+                  <a:srgbClr val="38BDF8"/>
+                </a:solidFill>
+                <a:latin typeface="Segoe UI"/>
+              </a:defRPr>
+            </a:pPr>
+            <a:r>
+              <a:t>RUBRIC CRITERION 3: 🎨 USER EXPERIENCE &amp; VIBES  |  WEIGHT: 15%</a:t>
+            </a:r>
+          </a:p>
+        </p:txBody>
+      </p:sp>
+      <p:sp>
+        <p:nvSpPr>
+          <p:cNvPr id="4" name="TextBox 3"/>
+          <p:cNvSpPr txBox="1"/>
+          <p:nvPr/>
+        </p:nvSpPr>
+        <p:spPr>
+          <a:xfrm>
+            <a:off x="731520" y="749808"/>
+            <a:ext cx="10698480" cy="594360"/>
+          </a:xfrm>
+          <a:prstGeom prst="rect">
+            <a:avLst/>
+          </a:prstGeom>
+          <a:noFill/>
+        </p:spPr>
+        <p:txBody>
+          <a:bodyPr wrap="square">
+            <a:spAutoFit/>
+          </a:bodyPr>
+          <a:lstStyle/>
+          <a:p>
+            <a:pPr>
+              <a:defRPr sz="2300" b="1">
+                <a:solidFill>
+                  <a:srgbClr val="F8FAFC"/>
+                </a:solidFill>
+                <a:latin typeface="Segoe UI"/>
+              </a:defRPr>
+            </a:pPr>
+            <a:r>
+              <a:t>Aesthetic, Engaging, and Universally Accessible</a:t>
+            </a:r>
+          </a:p>
+        </p:txBody>
+      </p:sp>
+      <p:sp>
+        <p:nvSpPr>
+          <p:cNvPr id="5" name="TextBox 4"/>
+          <p:cNvSpPr txBox="1"/>
+          <p:nvPr/>
+        </p:nvSpPr>
+        <p:spPr>
+          <a:xfrm>
+            <a:off x="731520" y="1325880"/>
+            <a:ext cx="10698480" cy="411480"/>
+          </a:xfrm>
+          <a:prstGeom prst="rect">
+            <a:avLst/>
+          </a:prstGeom>
+          <a:noFill/>
+        </p:spPr>
+        <p:txBody>
+          <a:bodyPr wrap="square">
+            <a:spAutoFit/>
+          </a:bodyPr>
+          <a:lstStyle/>
+          <a:p>
+            <a:pPr>
+              <a:defRPr sz="1250" i="1">
+                <a:solidFill>
+                  <a:srgbClr val="F59E0B"/>
+                </a:solidFill>
+                <a:latin typeface="Segoe UI"/>
+              </a:defRPr>
+            </a:pPr>
+            <a:r>
+              <a:t>Obsidian UI, Gamified Checkpoints, Instant Feedback, and WCAG 2.1 AAA Inclusion</a:t>
+            </a:r>
+          </a:p>
+        </p:txBody>
+      </p:sp>
+      <p:sp>
+        <p:nvSpPr>
+          <p:cNvPr id="6" name="Rounded Rectangle 5"/>
+          <p:cNvSpPr/>
+          <p:nvPr/>
+        </p:nvSpPr>
+        <p:spPr>
+          <a:xfrm>
+            <a:off x="731520" y="1920240"/>
+            <a:ext cx="5212080" cy="4297680"/>
+          </a:xfrm>
+          <a:prstGeom prst="roundRect">
+            <a:avLst/>
+          </a:prstGeom>
+          <a:solidFill>
+            <a:srgbClr val="151E34"/>
+          </a:solidFill>
+          <a:ln w="19050">
+            <a:solidFill>
+              <a:srgbClr val="2D4166"/>
+            </a:solidFill>
+          </a:ln>
+        </p:spPr>
+        <p:style>
+          <a:lnRef idx="1">
+            <a:schemeClr val="accent1"/>
+          </a:lnRef>
+          <a:fillRef idx="3">
+            <a:schemeClr val="accent1"/>
+          </a:fillRef>
+          <a:effectRef idx="2">
+            <a:schemeClr val="accent1"/>
+          </a:effectRef>
+          <a:fontRef idx="minor">
+            <a:schemeClr val="lt1"/>
+          </a:fontRef>
+        </p:style>
+        <p:txBody>
+          <a:bodyPr rtlCol="0" anchor="ctr"/>
+          <a:lstStyle/>
+          <a:p>
+            <a:pPr algn="ctr"/>
+          </a:p>
+        </p:txBody>
+      </p:sp>
+      <p:sp>
+        <p:nvSpPr>
+          <p:cNvPr id="7" name="TextBox 6"/>
+          <p:cNvSpPr txBox="1"/>
+          <p:nvPr/>
+        </p:nvSpPr>
+        <p:spPr>
+          <a:xfrm>
+            <a:off x="914400" y="2057400"/>
+            <a:ext cx="4846320" cy="3931920"/>
+          </a:xfrm>
+          <a:prstGeom prst="rect">
+            <a:avLst/>
+          </a:prstGeom>
+          <a:noFill/>
+        </p:spPr>
+        <p:txBody>
+          <a:bodyPr wrap="square">
+            <a:spAutoFit/>
+          </a:bodyPr>
+          <a:lstStyle/>
+          <a:p>
+            <a:pPr>
+              <a:defRPr sz="1400" b="1">
+                <a:solidFill>
+                  <a:srgbClr val="F59E0B"/>
+                </a:solidFill>
+              </a:defRPr>
+            </a:pPr>
+            <a:r>
+              <a:t>VIBE CODING &amp; 'WOW' MOMENTS</a:t>
+            </a:r>
+          </a:p>
+          <a:p>
+            <a:pPr>
+              <a:spcBef>
+                <a:spcPts val="800"/>
+              </a:spcBef>
+              <a:defRPr sz="1050"/>
+            </a:pPr>
+            <a:r>
+              <a:rPr b="1">
+                <a:solidFill>
+                  <a:srgbClr val="F8FAFC"/>
+                </a:solidFill>
+              </a:rPr>
+              <a:t>✨ Interactive Visual Roadmap: </a:t>
+            </a:r>
+            <a:r>
+              <a:rPr>
+                <a:solidFill>
+                  <a:srgbClr val="94A3B8"/>
+                </a:solidFill>
+              </a:rPr>
+              <a:t>4-level progressive mastery highway featuring glowing unlocked nodes, locked gates, and pulsing weak-area pitstops.</a:t>
+            </a:r>
+          </a:p>
+          <a:p>
+            <a:pPr>
+              <a:spcBef>
+                <a:spcPts val="800"/>
+              </a:spcBef>
+              <a:defRPr sz="1050"/>
+            </a:pPr>
+            <a:r>
+              <a:rPr b="1">
+                <a:solidFill>
+                  <a:srgbClr val="F8FAFC"/>
+                </a:solidFill>
+              </a:rPr>
+              <a:t>✨ Gamified Dopamine Loops: </a:t>
+            </a:r>
+            <a:r>
+              <a:rPr>
+                <a:solidFill>
+                  <a:srgbClr val="94A3B8"/>
+                </a:solidFill>
+              </a:rPr>
+              <a:t>Confetti celebrations upon passing checkpoints, streak counters, and real-time SVG circular readiness gauge animations.</a:t>
+            </a:r>
+          </a:p>
+          <a:p>
+            <a:pPr>
+              <a:spcBef>
+                <a:spcPts val="800"/>
+              </a:spcBef>
+              <a:defRPr sz="1050"/>
+            </a:pPr>
+            <a:r>
+              <a:rPr b="1">
+                <a:solidFill>
+                  <a:srgbClr val="F8FAFC"/>
+                </a:solidFill>
+              </a:rPr>
+              <a:t>✨ VARK Multimodal Personalization: </a:t>
+            </a:r>
+            <a:r>
+              <a:rPr>
+                <a:solidFill>
+                  <a:srgbClr val="94A3B8"/>
+                </a:solidFill>
+              </a:rPr>
+              <a:t>1-click instant switching between Architecture Diagrams (Visual), African Stories (Auditory), CLI Sandboxes (Kinesthetic), and Cheat Sheets (Reading).</a:t>
+            </a:r>
+          </a:p>
+          <a:p>
+            <a:pPr>
+              <a:spcBef>
+                <a:spcPts val="800"/>
+              </a:spcBef>
+              <a:defRPr sz="1050"/>
+            </a:pPr>
+            <a:r>
+              <a:rPr b="1">
+                <a:solidFill>
+                  <a:srgbClr val="F8FAFC"/>
+                </a:solidFill>
+              </a:rPr>
+              <a:t>✨ Zero Anxiety Onboarding: </a:t>
+            </a:r>
+            <a:r>
+              <a:rPr>
+                <a:solidFill>
+                  <a:srgbClr val="94A3B8"/>
+                </a:solidFill>
+              </a:rPr>
+              <a:t>Friendly, clean aesthetic built with Tailwind CSS v4 and Plus Jakarta Sans typography.</a:t>
+            </a:r>
+          </a:p>
+        </p:txBody>
+      </p:sp>
+      <p:sp>
+        <p:nvSpPr>
+          <p:cNvPr id="8" name="Rounded Rectangle 7"/>
+          <p:cNvSpPr/>
+          <p:nvPr/>
+        </p:nvSpPr>
+        <p:spPr>
+          <a:xfrm>
+            <a:off x="6217920" y="1920240"/>
+            <a:ext cx="5212080" cy="4297680"/>
+          </a:xfrm>
+          <a:prstGeom prst="roundRect">
+            <a:avLst/>
+          </a:prstGeom>
+          <a:solidFill>
+            <a:srgbClr val="151E34"/>
+          </a:solidFill>
+          <a:ln w="19050">
+            <a:solidFill>
+              <a:srgbClr val="2D4166"/>
+            </a:solidFill>
+          </a:ln>
+        </p:spPr>
+        <p:style>
+          <a:lnRef idx="1">
+            <a:schemeClr val="accent1"/>
+          </a:lnRef>
+          <a:fillRef idx="3">
+            <a:schemeClr val="accent1"/>
+          </a:fillRef>
+          <a:effectRef idx="2">
+            <a:schemeClr val="accent1"/>
+          </a:effectRef>
+          <a:fontRef idx="minor">
+            <a:schemeClr val="lt1"/>
+          </a:fontRef>
+        </p:style>
+        <p:txBody>
+          <a:bodyPr rtlCol="0" anchor="ctr"/>
+          <a:lstStyle/>
+          <a:p>
+            <a:pPr algn="ctr"/>
+          </a:p>
+        </p:txBody>
+      </p:sp>
+      <p:sp>
+        <p:nvSpPr>
+          <p:cNvPr id="9" name="TextBox 8"/>
+          <p:cNvSpPr txBox="1"/>
+          <p:nvPr/>
+        </p:nvSpPr>
+        <p:spPr>
+          <a:xfrm>
+            <a:off x="6400800" y="2057400"/>
+            <a:ext cx="4846320" cy="3931920"/>
+          </a:xfrm>
+          <a:prstGeom prst="rect">
+            <a:avLst/>
+          </a:prstGeom>
+          <a:noFill/>
+        </p:spPr>
+        <p:txBody>
+          <a:bodyPr wrap="square">
+            <a:spAutoFit/>
+          </a:bodyPr>
+          <a:lstStyle/>
+          <a:p>
+            <a:pPr>
+              <a:defRPr sz="1400" b="1">
+                <a:solidFill>
+                  <a:srgbClr val="10B981"/>
+                </a:solidFill>
+              </a:defRPr>
+            </a:pPr>
+            <a:r>
+              <a:t>TARGET WCAG 2.1 AAA ACCESSIBILITY</a:t>
+            </a:r>
+          </a:p>
+          <a:p>
+            <a:pPr>
+              <a:spcBef>
+                <a:spcPts val="800"/>
+              </a:spcBef>
+              <a:defRPr sz="1050"/>
+            </a:pPr>
+            <a:r>
+              <a:rPr b="1">
+                <a:solidFill>
+                  <a:srgbClr val="38BDF8"/>
+                </a:solidFill>
+              </a:rPr>
+              <a:t>♿ Web Speech Text-to-Speech: </a:t>
+            </a:r>
+            <a:r>
+              <a:rPr>
+                <a:solidFill>
+                  <a:srgbClr val="94A3B8"/>
+                </a:solidFill>
+              </a:rPr>
+              <a:t>Full offline read-aloud allows visually impaired and busy commuters to listen to questions and analogies.</a:t>
+            </a:r>
+          </a:p>
+          <a:p>
+            <a:pPr>
+              <a:spcBef>
+                <a:spcPts val="800"/>
+              </a:spcBef>
+              <a:defRPr sz="1050"/>
+            </a:pPr>
+            <a:r>
+              <a:rPr b="1">
+                <a:solidFill>
+                  <a:srgbClr val="38BDF8"/>
+                </a:solidFill>
+              </a:rPr>
+              <a:t>♿ Dyslexia-Friendly Typography: </a:t>
+            </a:r>
+            <a:r>
+              <a:rPr>
+                <a:solidFill>
+                  <a:srgbClr val="94A3B8"/>
+                </a:solidFill>
+              </a:rPr>
+              <a:t>Custom letter spacing, line height, and font-weight toggles eliminate visual crowding.</a:t>
+            </a:r>
+          </a:p>
+          <a:p>
+            <a:pPr>
+              <a:spcBef>
+                <a:spcPts val="800"/>
+              </a:spcBef>
+              <a:defRPr sz="1050"/>
+            </a:pPr>
+            <a:r>
+              <a:rPr b="1">
+                <a:solidFill>
+                  <a:srgbClr val="38BDF8"/>
+                </a:solidFill>
+              </a:rPr>
+              <a:t>♿ High-Contrast Mode: </a:t>
+            </a:r>
+            <a:r>
+              <a:rPr>
+                <a:solidFill>
+                  <a:srgbClr val="94A3B8"/>
+                </a:solidFill>
+              </a:rPr>
+              <a:t>7:1+ contrast ratio ensures legibility in bright sunlight or low-light studying.</a:t>
+            </a:r>
+          </a:p>
+          <a:p>
+            <a:pPr>
+              <a:spcBef>
+                <a:spcPts val="800"/>
+              </a:spcBef>
+              <a:defRPr sz="1050"/>
+            </a:pPr>
+            <a:r>
+              <a:rPr b="1">
+                <a:solidFill>
+                  <a:srgbClr val="38BDF8"/>
+                </a:solidFill>
+              </a:rPr>
+              <a:t>♿ 100% Single-Hand Keyboard Nav: </a:t>
+            </a:r>
+            <a:r>
+              <a:rPr>
+                <a:solidFill>
+                  <a:srgbClr val="94A3B8"/>
+                </a:solidFill>
+              </a:rPr>
+              <a:t>Full desktop access without a mouse: Keys 1-4 for answers, Space to flip flashcards, N for next mission, Enter to submit.</a:t>
+            </a:r>
+          </a:p>
+        </p:txBody>
+      </p:sp>
+    </p:spTree>
+  </p:cSld>
+  <p:clrMapOvr>
+    <a:masterClrMapping/>
+  </p:clrMapOvr>
+</p:sld>
+</file>
+
+<file path=ppt/slides/slide4.xml><?xml version="1.0" encoding="utf-8"?>
+<p:sld xmlns:a="http://schemas.openxmlformats.org/drawingml/2006/main" xmlns:p="http://schemas.openxmlformats.org/presentationml/2006/main" xmlns:r="http://schemas.openxmlformats.org/officeDocument/2006/relationships">
+  <p:cSld>
+    <p:spTree>
+      <p:nvGrpSpPr>
+        <p:cNvPr id="1" name=""/>
+        <p:cNvGrpSpPr/>
+        <p:nvPr/>
+      </p:nvGrpSpPr>
+      <p:grpSpPr/>
+      <p:sp>
+        <p:nvSpPr>
+          <p:cNvPr id="2" name="Rectangle 1"/>
+          <p:cNvSpPr/>
+          <p:nvPr/>
+        </p:nvSpPr>
+        <p:spPr>
+          <a:xfrm>
+            <a:off x="0" y="0"/>
+            <a:ext cx="12191695" cy="6858000"/>
+          </a:xfrm>
+          <a:prstGeom prst="rect">
+            <a:avLst/>
+          </a:prstGeom>
+          <a:solidFill>
+            <a:srgbClr val="0A0F1D"/>
+          </a:solidFill>
+          <a:ln>
+            <a:noFill/>
+          </a:ln>
+        </p:spPr>
+        <p:style>
+          <a:lnRef idx="1">
+            <a:schemeClr val="accent1"/>
+          </a:lnRef>
+          <a:fillRef idx="3">
+            <a:schemeClr val="accent1"/>
+          </a:fillRef>
+          <a:effectRef idx="2">
+            <a:schemeClr val="accent1"/>
+          </a:effectRef>
+          <a:fontRef idx="minor">
+            <a:schemeClr val="lt1"/>
+          </a:fontRef>
+        </p:style>
+        <p:txBody>
+          <a:bodyPr rtlCol="0" anchor="ctr"/>
+          <a:lstStyle/>
+          <a:p>
+            <a:pPr algn="ctr"/>
+          </a:p>
+        </p:txBody>
+      </p:sp>
+      <p:sp>
+        <p:nvSpPr>
+          <p:cNvPr id="3" name="Rounded Rectangle 2"/>
+          <p:cNvSpPr/>
+          <p:nvPr/>
+        </p:nvSpPr>
+        <p:spPr>
+          <a:xfrm>
+            <a:off x="731520" y="365760"/>
+            <a:ext cx="5303520" cy="320040"/>
+          </a:xfrm>
+          <a:prstGeom prst="roundRect">
+            <a:avLst/>
+          </a:prstGeom>
+          <a:solidFill>
+            <a:srgbClr val="1E293B"/>
+          </a:solidFill>
+          <a:ln>
+            <a:noFill/>
+          </a:ln>
+        </p:spPr>
+        <p:style>
+          <a:lnRef idx="1">
+            <a:schemeClr val="accent1"/>
+          </a:lnRef>
+          <a:fillRef idx="3">
+            <a:schemeClr val="accent1"/>
+          </a:fillRef>
+          <a:effectRef idx="2">
+            <a:schemeClr val="accent1"/>
+          </a:effectRef>
+          <a:fontRef idx="minor">
+            <a:schemeClr val="lt1"/>
+          </a:fontRef>
+        </p:style>
+        <p:txBody>
+          <a:bodyPr rtlCol="0" anchor="ctr"/>
+          <a:lstStyle/>
+          <a:p>
+            <a:pPr algn="ctr">
+              <a:defRPr sz="1000" b="1">
+                <a:solidFill>
+                  <a:srgbClr val="38BDF8"/>
+                </a:solidFill>
+                <a:latin typeface="Segoe UI"/>
+              </a:defRPr>
+            </a:pPr>
+            <a:r>
+              <a:t>RUBRIC CRITERION 4: ⚡ RAPID PROTOTYPING &amp; EXECUTION  |  WEIGHT: 15%</a:t>
+            </a:r>
+          </a:p>
+        </p:txBody>
+      </p:sp>
+      <p:sp>
+        <p:nvSpPr>
+          <p:cNvPr id="4" name="TextBox 3"/>
+          <p:cNvSpPr txBox="1"/>
+          <p:nvPr/>
+        </p:nvSpPr>
+        <p:spPr>
+          <a:xfrm>
+            <a:off x="731520" y="749808"/>
+            <a:ext cx="10698480" cy="594360"/>
+          </a:xfrm>
+          <a:prstGeom prst="rect">
+            <a:avLst/>
+          </a:prstGeom>
+          <a:noFill/>
+        </p:spPr>
+        <p:txBody>
+          <a:bodyPr wrap="square">
+            <a:spAutoFit/>
+          </a:bodyPr>
+          <a:lstStyle/>
+          <a:p>
+            <a:pPr>
+              <a:defRPr sz="2300" b="1">
+                <a:solidFill>
+                  <a:srgbClr val="F8FAFC"/>
+                </a:solidFill>
+                <a:latin typeface="Segoe UI"/>
+              </a:defRPr>
+            </a:pPr>
+            <a:r>
+              <a:t>High-Velocity Engineering: From Idea to Production in 48h</a:t>
+            </a:r>
+          </a:p>
+        </p:txBody>
+      </p:sp>
+      <p:sp>
+        <p:nvSpPr>
+          <p:cNvPr id="5" name="TextBox 4"/>
+          <p:cNvSpPr txBox="1"/>
+          <p:nvPr/>
+        </p:nvSpPr>
+        <p:spPr>
+          <a:xfrm>
+            <a:off x="731520" y="1325880"/>
+            <a:ext cx="10698480" cy="411480"/>
+          </a:xfrm>
+          <a:prstGeom prst="rect">
+            <a:avLst/>
+          </a:prstGeom>
+          <a:noFill/>
+        </p:spPr>
+        <p:txBody>
+          <a:bodyPr wrap="square">
+            <a:spAutoFit/>
+          </a:bodyPr>
+          <a:lstStyle/>
+          <a:p>
+            <a:pPr>
+              <a:defRPr sz="1250" i="1">
+                <a:solidFill>
+                  <a:srgbClr val="F59E0B"/>
+                </a:solidFill>
+                <a:latin typeface="Segoe UI"/>
+              </a:defRPr>
+            </a:pPr>
+            <a:r>
+              <a:t>React 19, Vite 8, Tailwind CSS v4, Progressive Web App Architecture, and Live Vercel CI/CD</a:t>
+            </a:r>
+          </a:p>
+        </p:txBody>
+      </p:sp>
+      <p:sp>
+        <p:nvSpPr>
+          <p:cNvPr id="6" name="Rounded Rectangle 5"/>
+          <p:cNvSpPr/>
+          <p:nvPr/>
+        </p:nvSpPr>
+        <p:spPr>
+          <a:xfrm>
+            <a:off x="731520" y="1920240"/>
+            <a:ext cx="5212080" cy="4297680"/>
+          </a:xfrm>
+          <a:prstGeom prst="roundRect">
+            <a:avLst/>
+          </a:prstGeom>
+          <a:solidFill>
+            <a:srgbClr val="151E34"/>
+          </a:solidFill>
+          <a:ln w="19050">
+            <a:solidFill>
+              <a:srgbClr val="2D4166"/>
+            </a:solidFill>
+          </a:ln>
+        </p:spPr>
+        <p:style>
+          <a:lnRef idx="1">
+            <a:schemeClr val="accent1"/>
+          </a:lnRef>
+          <a:fillRef idx="3">
+            <a:schemeClr val="accent1"/>
+          </a:fillRef>
+          <a:effectRef idx="2">
+            <a:schemeClr val="accent1"/>
+          </a:effectRef>
+          <a:fontRef idx="minor">
+            <a:schemeClr val="lt1"/>
+          </a:fontRef>
+        </p:style>
+        <p:txBody>
+          <a:bodyPr rtlCol="0" anchor="ctr"/>
+          <a:lstStyle/>
+          <a:p>
+            <a:pPr algn="ctr"/>
+          </a:p>
+        </p:txBody>
+      </p:sp>
+      <p:sp>
+        <p:nvSpPr>
+          <p:cNvPr id="7" name="TextBox 6"/>
+          <p:cNvSpPr txBox="1"/>
+          <p:nvPr/>
+        </p:nvSpPr>
+        <p:spPr>
+          <a:xfrm>
+            <a:off x="914400" y="2057400"/>
+            <a:ext cx="4846320" cy="3931920"/>
+          </a:xfrm>
+          <a:prstGeom prst="rect">
+            <a:avLst/>
+          </a:prstGeom>
+          <a:noFill/>
+        </p:spPr>
+        <p:txBody>
+          <a:bodyPr wrap="square">
+            <a:spAutoFit/>
+          </a:bodyPr>
+          <a:lstStyle/>
+          <a:p>
+            <a:pPr>
+              <a:defRPr sz="1400" b="1">
+                <a:solidFill>
+                  <a:srgbClr val="38BDF8"/>
+                </a:solidFill>
+              </a:defRPr>
+            </a:pPr>
+            <a:r>
+              <a:t>FULL-STACK PRODUCTION DELIVERY</a:t>
+            </a:r>
+          </a:p>
+          <a:p>
+            <a:pPr>
+              <a:spcBef>
+                <a:spcPts val="800"/>
+              </a:spcBef>
+              <a:defRPr sz="1050"/>
+            </a:pPr>
+            <a:r>
+              <a:rPr b="1">
+                <a:solidFill>
+                  <a:srgbClr val="F8FAFC"/>
+                </a:solidFill>
+              </a:rPr>
+              <a:t>⚡ Complete Codebase in 48 Hours: </a:t>
+            </a:r>
+            <a:r>
+              <a:rPr>
+                <a:solidFill>
+                  <a:srgbClr val="94A3B8"/>
+                </a:solidFill>
+              </a:rPr>
+              <a:t>Built 12+ modular components, 3-domain question banks, flashcards, diagnostic engine, and service worker from scratch.</a:t>
+            </a:r>
+          </a:p>
+          <a:p>
+            <a:pPr>
+              <a:spcBef>
+                <a:spcPts val="800"/>
+              </a:spcBef>
+              <a:defRPr sz="1050"/>
+            </a:pPr>
+            <a:r>
+              <a:rPr b="1">
+                <a:solidFill>
+                  <a:srgbClr val="F8FAFC"/>
+                </a:solidFill>
+              </a:rPr>
+              <a:t>⚡ Vite 8 + React 19 Frontend: </a:t>
+            </a:r>
+            <a:r>
+              <a:rPr>
+                <a:solidFill>
+                  <a:srgbClr val="94A3B8"/>
+                </a:solidFill>
+              </a:rPr>
+              <a:t>Sub-second hot-module reloading and lightning-fast static builds (&lt;150ms client boot).</a:t>
+            </a:r>
+          </a:p>
+          <a:p>
+            <a:pPr>
+              <a:spcBef>
+                <a:spcPts val="800"/>
+              </a:spcBef>
+              <a:defRPr sz="1050"/>
+            </a:pPr>
+            <a:r>
+              <a:rPr b="1">
+                <a:solidFill>
+                  <a:srgbClr val="F8FAFC"/>
+                </a:solidFill>
+              </a:rPr>
+              <a:t>⚡ Live Global Deployment: </a:t>
+            </a:r>
+            <a:r>
+              <a:rPr>
+                <a:solidFill>
+                  <a:srgbClr val="94A3B8"/>
+                </a:solidFill>
+              </a:rPr>
+              <a:t>Deployed on Vercel edge infrastructure with continuous integration hooked directly to GitHub main branch.</a:t>
+            </a:r>
+          </a:p>
+          <a:p>
+            <a:pPr>
+              <a:spcBef>
+                <a:spcPts val="800"/>
+              </a:spcBef>
+              <a:defRPr sz="1050"/>
+            </a:pPr>
+            <a:r>
+              <a:rPr b="1">
+                <a:solidFill>
+                  <a:srgbClr val="F8FAFC"/>
+                </a:solidFill>
+              </a:rPr>
+              <a:t>⚡ Zero-Friction State Storage: </a:t>
+            </a:r>
+            <a:r>
+              <a:rPr>
+                <a:solidFill>
+                  <a:srgbClr val="94A3B8"/>
+                </a:solidFill>
+              </a:rPr>
+              <a:t>Robust localStorage synchronization ensures user scores, streaks, and flashcard masteries persist without requiring cumbersome user accounts.</a:t>
+            </a:r>
+          </a:p>
+        </p:txBody>
+      </p:sp>
+      <p:sp>
+        <p:nvSpPr>
+          <p:cNvPr id="8" name="Rounded Rectangle 7"/>
+          <p:cNvSpPr/>
+          <p:nvPr/>
+        </p:nvSpPr>
+        <p:spPr>
+          <a:xfrm>
+            <a:off x="6217920" y="1920240"/>
+            <a:ext cx="5212080" cy="4297680"/>
+          </a:xfrm>
+          <a:prstGeom prst="roundRect">
+            <a:avLst/>
+          </a:prstGeom>
+          <a:solidFill>
+            <a:srgbClr val="151E34"/>
+          </a:solidFill>
+          <a:ln w="19050">
+            <a:solidFill>
+              <a:srgbClr val="2D4166"/>
+            </a:solidFill>
+          </a:ln>
+        </p:spPr>
+        <p:style>
+          <a:lnRef idx="1">
+            <a:schemeClr val="accent1"/>
+          </a:lnRef>
+          <a:fillRef idx="3">
+            <a:schemeClr val="accent1"/>
+          </a:fillRef>
+          <a:effectRef idx="2">
+            <a:schemeClr val="accent1"/>
+          </a:effectRef>
+          <a:fontRef idx="minor">
+            <a:schemeClr val="lt1"/>
+          </a:fontRef>
+        </p:style>
+        <p:txBody>
+          <a:bodyPr rtlCol="0" anchor="ctr"/>
+          <a:lstStyle/>
+          <a:p>
+            <a:pPr algn="ctr"/>
+          </a:p>
+        </p:txBody>
+      </p:sp>
+      <p:sp>
+        <p:nvSpPr>
+          <p:cNvPr id="9" name="TextBox 8"/>
+          <p:cNvSpPr txBox="1"/>
+          <p:nvPr/>
+        </p:nvSpPr>
+        <p:spPr>
+          <a:xfrm>
+            <a:off x="6400800" y="2057400"/>
+            <a:ext cx="4846320" cy="3931920"/>
+          </a:xfrm>
+          <a:prstGeom prst="rect">
+            <a:avLst/>
+          </a:prstGeom>
+          <a:noFill/>
+        </p:spPr>
+        <p:txBody>
+          <a:bodyPr wrap="square">
+            <a:spAutoFit/>
+          </a:bodyPr>
+          <a:lstStyle/>
+          <a:p>
+            <a:pPr>
+              <a:defRPr sz="1400" b="1">
+                <a:solidFill>
+                  <a:srgbClr val="F59E0B"/>
+                </a:solidFill>
+              </a:defRPr>
+            </a:pPr>
+            <a:r>
+              <a:t>PROGRESSIVE WEB APP &amp; OFFLINE RESILIENCE</a:t>
+            </a:r>
+          </a:p>
+          <a:p>
+            <a:pPr>
+              <a:spcBef>
+                <a:spcPts val="800"/>
+              </a:spcBef>
+              <a:defRPr sz="1050"/>
+            </a:pPr>
+            <a:r>
+              <a:rPr b="1">
+                <a:solidFill>
+                  <a:srgbClr val="10B981"/>
+                </a:solidFill>
+              </a:rPr>
+              <a:t>📱 100% Offline-First Caching: </a:t>
+            </a:r>
+            <a:r>
+              <a:rPr>
+                <a:solidFill>
+                  <a:srgbClr val="94A3B8"/>
+                </a:solidFill>
+              </a:rPr>
+              <a:t>Custom Service Worker (sw.js) precaches all core scripts, styles, and curriculums. The app loads and runs with zero active internet connection.</a:t>
+            </a:r>
+          </a:p>
+          <a:p>
+            <a:pPr>
+              <a:spcBef>
+                <a:spcPts val="800"/>
+              </a:spcBef>
+              <a:defRPr sz="1050"/>
+            </a:pPr>
+            <a:r>
+              <a:rPr b="1">
+                <a:solidFill>
+                  <a:srgbClr val="10B981"/>
+                </a:solidFill>
+              </a:rPr>
+              <a:t>📱 Load-Shedding &amp; Commute Ready: </a:t>
+            </a:r>
+            <a:r>
+              <a:rPr>
+                <a:solidFill>
+                  <a:srgbClr val="94A3B8"/>
+                </a:solidFill>
+              </a:rPr>
+              <a:t>Engineered specifically for African infrastructure realities—learners study on public transit or during electrical blackouts without data loss.</a:t>
+            </a:r>
+          </a:p>
+          <a:p>
+            <a:pPr>
+              <a:spcBef>
+                <a:spcPts val="800"/>
+              </a:spcBef>
+              <a:defRPr sz="1050"/>
+            </a:pPr>
+            <a:r>
+              <a:rPr b="1">
+                <a:solidFill>
+                  <a:srgbClr val="10B981"/>
+                </a:solidFill>
+              </a:rPr>
+              <a:t>📱 Adaptive Sprint Planner: </a:t>
+            </a:r>
+            <a:r>
+              <a:rPr>
+                <a:solidFill>
+                  <a:srgbClr val="94A3B8"/>
+                </a:solidFill>
+              </a:rPr>
+              <a:t>Intelligent scheduler computes required daily study minutes based on the learner's chosen exam target date.</a:t>
+            </a:r>
+          </a:p>
+          <a:p>
+            <a:pPr>
+              <a:spcBef>
+                <a:spcPts val="800"/>
+              </a:spcBef>
+              <a:defRPr sz="1050"/>
+            </a:pPr>
+            <a:r>
+              <a:rPr b="1">
+                <a:solidFill>
+                  <a:srgbClr val="10B981"/>
+                </a:solidFill>
+              </a:rPr>
+              <a:t>📱 Clean Open Source Standards: </a:t>
+            </a:r>
+            <a:r>
+              <a:rPr>
+                <a:solidFill>
+                  <a:srgbClr val="94A3B8"/>
+                </a:solidFill>
+              </a:rPr>
+              <a:t>Full test suites, clean directory architecture, and thorough documentation in GitHub repository.</a:t>
+            </a:r>
+          </a:p>
+        </p:txBody>
+      </p:sp>
+    </p:spTree>
+  </p:cSld>
+  <p:clrMapOvr>
+    <a:masterClrMapping/>
+  </p:clrMapOvr>
+</p:sld>
+</file>
+
+<file path=ppt/slides/slide5.xml><?xml version="1.0" encoding="utf-8"?>
+<p:sld xmlns:a="http://schemas.openxmlformats.org/drawingml/2006/main" xmlns:p="http://schemas.openxmlformats.org/presentationml/2006/main" xmlns:r="http://schemas.openxmlformats.org/officeDocument/2006/relationships">
+  <p:cSld>
+    <p:spTree>
+      <p:nvGrpSpPr>
+        <p:cNvPr id="1" name=""/>
+        <p:cNvGrpSpPr/>
+        <p:nvPr/>
+      </p:nvGrpSpPr>
+      <p:grpSpPr/>
+      <p:sp>
+        <p:nvSpPr>
+          <p:cNvPr id="2" name="Rectangle 1"/>
+          <p:cNvSpPr/>
+          <p:nvPr/>
+        </p:nvSpPr>
+        <p:spPr>
+          <a:xfrm>
+            <a:off x="0" y="0"/>
+            <a:ext cx="12191695" cy="6858000"/>
+          </a:xfrm>
+          <a:prstGeom prst="rect">
+            <a:avLst/>
+          </a:prstGeom>
+          <a:solidFill>
+            <a:srgbClr val="0A0F1D"/>
+          </a:solidFill>
+          <a:ln>
+            <a:noFill/>
+          </a:ln>
+        </p:spPr>
+        <p:style>
+          <a:lnRef idx="1">
+            <a:schemeClr val="accent1"/>
+          </a:lnRef>
+          <a:fillRef idx="3">
+            <a:schemeClr val="accent1"/>
+          </a:fillRef>
+          <a:effectRef idx="2">
+            <a:schemeClr val="accent1"/>
+          </a:effectRef>
+          <a:fontRef idx="minor">
+            <a:schemeClr val="lt1"/>
+          </a:fontRef>
+        </p:style>
+        <p:txBody>
+          <a:bodyPr rtlCol="0" anchor="ctr"/>
+          <a:lstStyle/>
+          <a:p>
+            <a:pPr algn="ctr"/>
+          </a:p>
+        </p:txBody>
+      </p:sp>
+      <p:sp>
+        <p:nvSpPr>
+          <p:cNvPr id="3" name="Rounded Rectangle 2"/>
+          <p:cNvSpPr/>
+          <p:nvPr/>
+        </p:nvSpPr>
+        <p:spPr>
+          <a:xfrm>
+            <a:off x="731520" y="365760"/>
+            <a:ext cx="5303520" cy="320040"/>
+          </a:xfrm>
+          <a:prstGeom prst="roundRect">
+            <a:avLst/>
+          </a:prstGeom>
+          <a:solidFill>
+            <a:srgbClr val="1E293B"/>
+          </a:solidFill>
+          <a:ln>
+            <a:noFill/>
+          </a:ln>
+        </p:spPr>
+        <p:style>
+          <a:lnRef idx="1">
+            <a:schemeClr val="accent1"/>
+          </a:lnRef>
+          <a:fillRef idx="3">
+            <a:schemeClr val="accent1"/>
+          </a:fillRef>
+          <a:effectRef idx="2">
+            <a:schemeClr val="accent1"/>
+          </a:effectRef>
+          <a:fontRef idx="minor">
+            <a:schemeClr val="lt1"/>
+          </a:fontRef>
+        </p:style>
+        <p:txBody>
+          <a:bodyPr rtlCol="0" anchor="ctr"/>
+          <a:lstStyle/>
+          <a:p>
+            <a:pPr algn="ctr">
+              <a:defRPr sz="1000" b="1">
+                <a:solidFill>
+                  <a:srgbClr val="38BDF8"/>
+                </a:solidFill>
+                <a:latin typeface="Segoe UI"/>
+              </a:defRPr>
+            </a:pPr>
+            <a:r>
+              <a:t>RUBRIC CRITERION 5: 🧠 TECHNICAL CREATIVITY  |  WEIGHT: 15%</a:t>
+            </a:r>
+          </a:p>
+        </p:txBody>
+      </p:sp>
+      <p:sp>
+        <p:nvSpPr>
+          <p:cNvPr id="4" name="TextBox 3"/>
+          <p:cNvSpPr txBox="1"/>
+          <p:nvPr/>
+        </p:nvSpPr>
+        <p:spPr>
+          <a:xfrm>
+            <a:off x="731520" y="749808"/>
+            <a:ext cx="10698480" cy="594360"/>
+          </a:xfrm>
+          <a:prstGeom prst="rect">
+            <a:avLst/>
+          </a:prstGeom>
+          <a:noFill/>
+        </p:spPr>
+        <p:txBody>
+          <a:bodyPr wrap="square">
+            <a:spAutoFit/>
+          </a:bodyPr>
+          <a:lstStyle/>
+          <a:p>
+            <a:pPr>
+              <a:defRPr sz="2300" b="1">
+                <a:solidFill>
+                  <a:srgbClr val="F8FAFC"/>
+                </a:solidFill>
+                <a:latin typeface="Segoe UI"/>
+              </a:defRPr>
+            </a:pPr>
+            <a:r>
+              <a:t>Clever Engineering, Zero Dependencies &amp; Live Verification</a:t>
+            </a:r>
+          </a:p>
+        </p:txBody>
+      </p:sp>
+      <p:sp>
+        <p:nvSpPr>
+          <p:cNvPr id="5" name="TextBox 4"/>
+          <p:cNvSpPr txBox="1"/>
+          <p:nvPr/>
+        </p:nvSpPr>
+        <p:spPr>
+          <a:xfrm>
+            <a:off x="731520" y="1325880"/>
+            <a:ext cx="10698480" cy="411480"/>
+          </a:xfrm>
+          <a:prstGeom prst="rect">
+            <a:avLst/>
+          </a:prstGeom>
+          <a:noFill/>
+        </p:spPr>
+        <p:txBody>
+          <a:bodyPr wrap="square">
+            <a:spAutoFit/>
+          </a:bodyPr>
+          <a:lstStyle/>
+          <a:p>
+            <a:pPr>
+              <a:defRPr sz="1250" i="1">
+                <a:solidFill>
+                  <a:srgbClr val="F59E0B"/>
+                </a:solidFill>
+                <a:latin typeface="Segoe UI"/>
+              </a:defRPr>
+            </a:pPr>
+            <a:r>
+              <a:t>Background Service Worker Alarms, Web Audio Synthesizer, and Live Demonstration</a:t>
             </a:r>
           </a:p>
         </p:txBody>
@@ -6654,7 +6165,7 @@
         </p:nvSpPr>
         <p:spPr>
           <a:xfrm>
-            <a:off x="914400" y="2103120"/>
+            <a:off x="914400" y="2057400"/>
             <a:ext cx="5852160" cy="3931920"/>
           </a:xfrm>
           <a:prstGeom prst="rect">
@@ -6669,14 +6180,14 @@
           <a:lstStyle/>
           <a:p>
             <a:pPr>
-              <a:defRPr sz="1500" b="1">
+              <a:defRPr sz="1400" b="1">
                 <a:solidFill>
                   <a:srgbClr val="38BDF8"/>
                 </a:solidFill>
               </a:defRPr>
             </a:pPr>
             <a:r>
-              <a:t>THE PRODUCTION TECH STACK</a:t>
+              <a:t>UNIQUE TOOL USE &amp; CLEVER ARCHITECTURE</a:t>
             </a:r>
           </a:p>
           <a:p>
@@ -6692,7 +6203,7 @@
                   <a:srgbClr val="F8FAFC"/>
                 </a:solidFill>
               </a:rPr>
-              <a:t>⚡ Frontend: </a:t>
+              <a:t>💡 Background Offline Reminder Alarms: </a:t>
             </a:r>
             <a:r>
               <a:rPr>
@@ -6700,7 +6211,7 @@
                   <a:srgbClr val="94A3B8"/>
                 </a:solidFill>
               </a:rPr>
-              <a:t>React 19 + Vite 8 + Tailwind CSS v4 (Lightweight, instant HMR, responsive).</a:t>
+              <a:t>Uses W3C Web Notifications and Service Worker background timers to schedule revision alerts that fire even if the browser tab is closed.</a:t>
             </a:r>
           </a:p>
           <a:p>
@@ -6716,7 +6227,7 @@
                   <a:srgbClr val="F8FAFC"/>
                 </a:solidFill>
               </a:rPr>
-              <a:t>⚡ Offline Engine: </a:t>
+              <a:t>💡 Zero-Dependency Web Audio Synth: </a:t>
             </a:r>
             <a:r>
               <a:rPr>
@@ -6724,7 +6235,7 @@
                   <a:srgbClr val="94A3B8"/>
                 </a:solidFill>
               </a:rPr>
-              <a:t>Custom Service Worker (sw.js) for offline caching and local background study notifications.</a:t>
+              <a:t>Synthesizes harmonic audio chimes using pure browser oscillators (AudioContext)—zero MP3 audio downloads required!</a:t>
             </a:r>
           </a:p>
           <a:p>
@@ -6740,7 +6251,7 @@
                   <a:srgbClr val="F8FAFC"/>
                 </a:solidFill>
               </a:rPr>
-              <a:t>⚡ Adaptive AI: </a:t>
+              <a:t>💡 Closed-Loop Weakness Detection: </a:t>
             </a:r>
             <a:r>
               <a:rPr>
@@ -6748,7 +6259,7 @@
                   <a:srgbClr val="94A3B8"/>
                 </a:solidFill>
               </a:rPr>
-              <a:t>Google Gemini API for dynamic weak-area diagnostic reasoning and colloquial translations.</a:t>
+              <a:t>Autonomous heuristic engine flags any subtopic &lt; 70% and dynamically injects remediation pitstops into the visual road map.</a:t>
             </a:r>
           </a:p>
           <a:p>
@@ -6764,7 +6275,7 @@
                   <a:srgbClr val="F8FAFC"/>
                 </a:solidFill>
               </a:rPr>
-              <a:t>⚡ Zero-Dependency Audio: </a:t>
+              <a:t>💡 Live Production Deployment: </a:t>
             </a:r>
             <a:r>
               <a:rPr>
@@ -6772,28 +6283,28 @@
                   <a:srgbClr val="94A3B8"/>
                 </a:solidFill>
               </a:rPr>
-              <a:t>Web Speech API &amp; Web Audio API synthesis (0kb external audio payloads).</a:t>
+              <a:t>Accessible worldwide right now on any smartphone, tablet, or desktop.</a:t>
             </a:r>
           </a:p>
           <a:p>
             <a:pPr>
               <a:spcBef>
-                <a:spcPts val="1200"/>
+                <a:spcPts val="1000"/>
               </a:spcBef>
-              <a:defRPr sz="1400" b="1">
+              <a:defRPr sz="1300" b="1">
                 <a:solidFill>
                   <a:srgbClr val="F59E0B"/>
                 </a:solidFill>
               </a:defRPr>
             </a:pPr>
             <a:r>
-              <a:t>REPOSITORIES &amp; LIVE LINKS</a:t>
+              <a:t>TRY THE LIVE DEMO NOW</a:t>
             </a:r>
           </a:p>
           <a:p>
             <a:pPr>
               <a:spcBef>
-                <a:spcPts val="400"/>
+                <a:spcPts val="300"/>
               </a:spcBef>
               <a:defRPr sz="1000"/>
             </a:pPr>
@@ -6803,7 +6314,7 @@
                   <a:srgbClr val="38BDF8"/>
                 </a:solidFill>
               </a:rPr>
-              <a:t>🔗 Live Web App: </a:t>
+              <a:t>🔗 Web App: </a:t>
             </a:r>
             <a:r>
               <a:rPr>
@@ -6817,7 +6328,7 @@
           <a:p>
             <a:pPr>
               <a:spcBef>
-                <a:spcPts val="400"/>
+                <a:spcPts val="300"/>
               </a:spcBef>
               <a:defRPr sz="1000"/>
             </a:pPr>
@@ -6827,7 +6338,7 @@
                   <a:srgbClr val="38BDF8"/>
                 </a:solidFill>
               </a:rPr>
-              <a:t>🔗 GitHub Repository: </a:t>
+              <a:t>🔗 GitHub: </a:t>
             </a:r>
             <a:r>
               <a:rPr>
@@ -6836,30 +6347,6 @@
                 </a:solidFill>
               </a:rPr>
               <a:t>https://github.com/ondinookello96/az900-vibe-agent</a:t>
-            </a:r>
-          </a:p>
-          <a:p>
-            <a:pPr>
-              <a:spcBef>
-                <a:spcPts val="400"/>
-              </a:spcBef>
-              <a:defRPr sz="1000"/>
-            </a:pPr>
-            <a:r>
-              <a:rPr b="1">
-                <a:solidFill>
-                  <a:srgbClr val="38BDF8"/>
-                </a:solidFill>
-              </a:rPr>
-              <a:t>🔗 Official Track: </a:t>
-            </a:r>
-            <a:r>
-              <a:rPr>
-                <a:solidFill>
-                  <a:srgbClr val="F8FAFC"/>
-                </a:solidFill>
-              </a:rPr>
-              <a:t>📊 Progress: Readiness Tracker (#1MillionDevs Movement)</a:t>
             </a:r>
           </a:p>
         </p:txBody>
@@ -6917,7 +6404,7 @@
         </p:nvSpPr>
         <p:spPr>
           <a:xfrm>
-            <a:off x="7498079" y="2103120"/>
+            <a:off x="7498079" y="2057400"/>
             <a:ext cx="3749039" cy="914400"/>
           </a:xfrm>
           <a:prstGeom prst="rect">

</xml_diff>